<commit_message>
feat(ge-erac): publish walkthrough deck with 13 real app screenshots (notes stripped)
</commit_message>
<xml_diff>
--- a/ppt/GE-ERAC-Walkthrough.pptx
+++ b/ppt/GE-ERAC-Walkthrough.pptx
@@ -2811,12 +2811,20 @@
           </a:p>
         </p:txBody>
       </p:sp>
-      <p:sp>
-        <p:nvSpPr>
-          <p:cNvPr id="7" name="Shape 5"/>
-          <p:cNvSpPr/>
-          <p:nvPr/>
-        </p:nvSpPr>
+      <p:pic>
+        <p:nvPicPr>
+          <p:cNvPr id="7" name="Image 0" descr="ppt\screens\projects_strategy.png">    </p:cNvPr>
+          <p:cNvPicPr>
+            <a:picLocks noChangeAspect="1"/>
+          </p:cNvPicPr>
+          <p:nvPr/>
+        </p:nvPicPr>
+        <p:blipFill>
+          <a:blip r:embed="rId1"/>
+          <a:stretch>
+            <a:fillRect/>
+          </a:stretch>
+        </p:blipFill>
         <p:spPr>
           <a:xfrm>
             <a:off x="457200" y="1691640"/>
@@ -2825,137 +2833,33 @@
           <a:prstGeom prst="rect">
             <a:avLst/>
           </a:prstGeom>
-          <a:solidFill>
-            <a:srgbClr val="F5F7FA"/>
-          </a:solidFill>
-          <a:ln w="19050">
+        </p:spPr>
+      </p:pic>
+      <p:sp>
+        <p:nvSpPr>
+          <p:cNvPr id="8" name="Shape 5"/>
+          <p:cNvSpPr/>
+          <p:nvPr/>
+        </p:nvSpPr>
+        <p:spPr>
+          <a:xfrm>
+            <a:off x="457200" y="1691640"/>
+            <a:ext cx="6858000" cy="4480560"/>
+          </a:xfrm>
+          <a:prstGeom prst="rect">
+            <a:avLst/>
+          </a:prstGeom>
+          <a:ln w="12700">
             <a:solidFill>
               <a:srgbClr val="E1DFDD"/>
             </a:solidFill>
-            <a:prstDash val="dash"/>
+            <a:prstDash val="solid"/>
           </a:ln>
         </p:spPr>
       </p:sp>
       <p:sp>
         <p:nvSpPr>
-          <p:cNvPr id="8" name="Text 6"/>
-          <p:cNvSpPr/>
-          <p:nvPr/>
-        </p:nvSpPr>
-        <p:spPr>
-          <a:xfrm>
-            <a:off x="457200" y="3474720"/>
-            <a:ext cx="6858000" cy="457200"/>
-          </a:xfrm>
-          <a:prstGeom prst="rect">
-            <a:avLst/>
-          </a:prstGeom>
-          <a:noFill/>
-          <a:ln/>
-        </p:spPr>
-        <p:txBody>
-          <a:bodyPr wrap="square" rtlCol="0" anchor="ctr"/>
-          <a:lstStyle/>
-          <a:p>
-            <a:pPr algn="ctr" indent="0" marL="0">
-              <a:buNone/>
-            </a:pPr>
-            <a:r>
-              <a:rPr lang="en-US" sz="1600" b="1" dirty="0">
-                <a:solidFill>
-                  <a:srgbClr val="8A8886"/>
-                </a:solidFill>
-                <a:latin typeface="Segoe UI" pitchFamily="34" charset="0"/>
-                <a:ea typeface="Segoe UI" pitchFamily="34" charset="-122"/>
-                <a:cs typeface="Segoe UI" pitchFamily="34" charset="-120"/>
-              </a:rPr>
-              <a:t>📷  Screenshot</a:t>
-            </a:r>
-            <a:endParaRPr lang="en-US" sz="1600" dirty="0"/>
-          </a:p>
-        </p:txBody>
-      </p:sp>
-      <p:sp>
-        <p:nvSpPr>
-          <p:cNvPr id="9" name="Text 7"/>
-          <p:cNvSpPr/>
-          <p:nvPr/>
-        </p:nvSpPr>
-        <p:spPr>
-          <a:xfrm>
-            <a:off x="731520" y="3977640"/>
-            <a:ext cx="6309360" cy="457200"/>
-          </a:xfrm>
-          <a:prstGeom prst="rect">
-            <a:avLst/>
-          </a:prstGeom>
-          <a:noFill/>
-          <a:ln/>
-        </p:spPr>
-        <p:txBody>
-          <a:bodyPr wrap="square" rtlCol="0" anchor="ctr"/>
-          <a:lstStyle/>
-          <a:p>
-            <a:pPr algn="ctr" indent="0" marL="0">
-              <a:buNone/>
-            </a:pPr>
-            <a:r>
-              <a:rPr lang="en-US" sz="1100" dirty="0">
-                <a:solidFill>
-                  <a:srgbClr val="8A8886"/>
-                </a:solidFill>
-                <a:latin typeface="Segoe UI" pitchFamily="34" charset="0"/>
-                <a:ea typeface="Segoe UI" pitchFamily="34" charset="-122"/>
-                <a:cs typeface="Segoe UI" pitchFamily="34" charset="-120"/>
-              </a:rPr>
-              <a:t>Analytics → Projects &amp; Strategy</a:t>
-            </a:r>
-            <a:endParaRPr lang="en-US" sz="1100" dirty="0"/>
-          </a:p>
-        </p:txBody>
-      </p:sp>
-      <p:sp>
-        <p:nvSpPr>
-          <p:cNvPr id="10" name="Text 8"/>
-          <p:cNvSpPr/>
-          <p:nvPr/>
-        </p:nvSpPr>
-        <p:spPr>
-          <a:xfrm>
-            <a:off x="457200" y="5760720"/>
-            <a:ext cx="6858000" cy="320040"/>
-          </a:xfrm>
-          <a:prstGeom prst="rect">
-            <a:avLst/>
-          </a:prstGeom>
-          <a:noFill/>
-          <a:ln/>
-        </p:spPr>
-        <p:txBody>
-          <a:bodyPr wrap="square" rtlCol="0" anchor="ctr"/>
-          <a:lstStyle/>
-          <a:p>
-            <a:pPr algn="ctr" indent="0" marL="0">
-              <a:buNone/>
-            </a:pPr>
-            <a:r>
-              <a:rPr lang="en-US" sz="900" i="1" dirty="0">
-                <a:solidFill>
-                  <a:srgbClr val="8A8886"/>
-                </a:solidFill>
-                <a:latin typeface="Segoe UI" pitchFamily="34" charset="0"/>
-                <a:ea typeface="Segoe UI" pitchFamily="34" charset="-122"/>
-                <a:cs typeface="Segoe UI" pitchFamily="34" charset="-120"/>
-              </a:rPr>
-              <a:t>Paste the live screen capture here</a:t>
-            </a:r>
-            <a:endParaRPr lang="en-US" sz="900" dirty="0"/>
-          </a:p>
-        </p:txBody>
-      </p:sp>
-      <p:sp>
-        <p:nvSpPr>
-          <p:cNvPr id="11" name="Text 9"/>
+          <p:cNvPr id="9" name="Text 6"/>
           <p:cNvSpPr/>
           <p:nvPr/>
         </p:nvSpPr>
@@ -2994,7 +2898,7 @@
       </p:sp>
       <p:sp>
         <p:nvSpPr>
-          <p:cNvPr id="12" name="Shape 10"/>
+          <p:cNvPr id="10" name="Shape 7"/>
           <p:cNvSpPr/>
           <p:nvPr/>
         </p:nvSpPr>
@@ -3014,7 +2918,7 @@
       </p:sp>
       <p:sp>
         <p:nvSpPr>
-          <p:cNvPr id="13" name="Text 11"/>
+          <p:cNvPr id="11" name="Text 8"/>
           <p:cNvSpPr/>
           <p:nvPr/>
         </p:nvSpPr>
@@ -3053,7 +2957,7 @@
       </p:sp>
       <p:sp>
         <p:nvSpPr>
-          <p:cNvPr id="14" name="Text 12"/>
+          <p:cNvPr id="12" name="Text 9"/>
           <p:cNvSpPr/>
           <p:nvPr/>
         </p:nvSpPr>
@@ -3092,7 +2996,7 @@
       </p:sp>
       <p:sp>
         <p:nvSpPr>
-          <p:cNvPr id="15" name="Text 13"/>
+          <p:cNvPr id="13" name="Text 10"/>
           <p:cNvSpPr/>
           <p:nvPr/>
         </p:nvSpPr>
@@ -3331,12 +3235,20 @@
           </a:p>
         </p:txBody>
       </p:sp>
-      <p:sp>
-        <p:nvSpPr>
-          <p:cNvPr id="5" name="Shape 3"/>
-          <p:cNvSpPr/>
-          <p:nvPr/>
-        </p:nvSpPr>
+      <p:pic>
+        <p:nvPicPr>
+          <p:cNvPr id="5" name="Image 0" descr="ppt\screens\strategy_studio.png">    </p:cNvPr>
+          <p:cNvPicPr>
+            <a:picLocks noChangeAspect="1"/>
+          </p:cNvPicPr>
+          <p:nvPr/>
+        </p:nvPicPr>
+        <p:blipFill>
+          <a:blip r:embed="rId1"/>
+          <a:stretch>
+            <a:fillRect/>
+          </a:stretch>
+        </p:blipFill>
         <p:spPr>
           <a:xfrm>
             <a:off x="457200" y="1691640"/>
@@ -3345,137 +3257,33 @@
           <a:prstGeom prst="rect">
             <a:avLst/>
           </a:prstGeom>
-          <a:solidFill>
-            <a:srgbClr val="F5F7FA"/>
-          </a:solidFill>
-          <a:ln w="19050">
+        </p:spPr>
+      </p:pic>
+      <p:sp>
+        <p:nvSpPr>
+          <p:cNvPr id="6" name="Shape 3"/>
+          <p:cNvSpPr/>
+          <p:nvPr/>
+        </p:nvSpPr>
+        <p:spPr>
+          <a:xfrm>
+            <a:off x="457200" y="1691640"/>
+            <a:ext cx="6858000" cy="4480560"/>
+          </a:xfrm>
+          <a:prstGeom prst="rect">
+            <a:avLst/>
+          </a:prstGeom>
+          <a:ln w="12700">
             <a:solidFill>
               <a:srgbClr val="E1DFDD"/>
             </a:solidFill>
-            <a:prstDash val="dash"/>
+            <a:prstDash val="solid"/>
           </a:ln>
         </p:spPr>
       </p:sp>
       <p:sp>
         <p:nvSpPr>
-          <p:cNvPr id="6" name="Text 4"/>
-          <p:cNvSpPr/>
-          <p:nvPr/>
-        </p:nvSpPr>
-        <p:spPr>
-          <a:xfrm>
-            <a:off x="457200" y="3474720"/>
-            <a:ext cx="6858000" cy="457200"/>
-          </a:xfrm>
-          <a:prstGeom prst="rect">
-            <a:avLst/>
-          </a:prstGeom>
-          <a:noFill/>
-          <a:ln/>
-        </p:spPr>
-        <p:txBody>
-          <a:bodyPr wrap="square" rtlCol="0" anchor="ctr"/>
-          <a:lstStyle/>
-          <a:p>
-            <a:pPr algn="ctr" indent="0" marL="0">
-              <a:buNone/>
-            </a:pPr>
-            <a:r>
-              <a:rPr lang="en-US" sz="1600" b="1" dirty="0">
-                <a:solidFill>
-                  <a:srgbClr val="8A8886"/>
-                </a:solidFill>
-                <a:latin typeface="Segoe UI" pitchFamily="34" charset="0"/>
-                <a:ea typeface="Segoe UI" pitchFamily="34" charset="-122"/>
-                <a:cs typeface="Segoe UI" pitchFamily="34" charset="-120"/>
-              </a:rPr>
-              <a:t>📷  Screenshot</a:t>
-            </a:r>
-            <a:endParaRPr lang="en-US" sz="1600" dirty="0"/>
-          </a:p>
-        </p:txBody>
-      </p:sp>
-      <p:sp>
-        <p:nvSpPr>
-          <p:cNvPr id="7" name="Text 5"/>
-          <p:cNvSpPr/>
-          <p:nvPr/>
-        </p:nvSpPr>
-        <p:spPr>
-          <a:xfrm>
-            <a:off x="731520" y="3977640"/>
-            <a:ext cx="6309360" cy="457200"/>
-          </a:xfrm>
-          <a:prstGeom prst="rect">
-            <a:avLst/>
-          </a:prstGeom>
-          <a:noFill/>
-          <a:ln/>
-        </p:spPr>
-        <p:txBody>
-          <a:bodyPr wrap="square" rtlCol="0" anchor="ctr"/>
-          <a:lstStyle/>
-          <a:p>
-            <a:pPr algn="ctr" indent="0" marL="0">
-              <a:buNone/>
-            </a:pPr>
-            <a:r>
-              <a:rPr lang="en-US" sz="1100" dirty="0">
-                <a:solidFill>
-                  <a:srgbClr val="8A8886"/>
-                </a:solidFill>
-                <a:latin typeface="Segoe UI" pitchFamily="34" charset="0"/>
-                <a:ea typeface="Segoe UI" pitchFamily="34" charset="-122"/>
-                <a:cs typeface="Segoe UI" pitchFamily="34" charset="-120"/>
-              </a:rPr>
-              <a:t>Analytics → Strategy Studio → UNUM → Approve → Review cadence</a:t>
-            </a:r>
-            <a:endParaRPr lang="en-US" sz="1100" dirty="0"/>
-          </a:p>
-        </p:txBody>
-      </p:sp>
-      <p:sp>
-        <p:nvSpPr>
-          <p:cNvPr id="8" name="Text 6"/>
-          <p:cNvSpPr/>
-          <p:nvPr/>
-        </p:nvSpPr>
-        <p:spPr>
-          <a:xfrm>
-            <a:off x="457200" y="5760720"/>
-            <a:ext cx="6858000" cy="320040"/>
-          </a:xfrm>
-          <a:prstGeom prst="rect">
-            <a:avLst/>
-          </a:prstGeom>
-          <a:noFill/>
-          <a:ln/>
-        </p:spPr>
-        <p:txBody>
-          <a:bodyPr wrap="square" rtlCol="0" anchor="ctr"/>
-          <a:lstStyle/>
-          <a:p>
-            <a:pPr algn="ctr" indent="0" marL="0">
-              <a:buNone/>
-            </a:pPr>
-            <a:r>
-              <a:rPr lang="en-US" sz="900" i="1" dirty="0">
-                <a:solidFill>
-                  <a:srgbClr val="8A8886"/>
-                </a:solidFill>
-                <a:latin typeface="Segoe UI" pitchFamily="34" charset="0"/>
-                <a:ea typeface="Segoe UI" pitchFamily="34" charset="-122"/>
-                <a:cs typeface="Segoe UI" pitchFamily="34" charset="-120"/>
-              </a:rPr>
-              <a:t>Paste the live screen capture here</a:t>
-            </a:r>
-            <a:endParaRPr lang="en-US" sz="900" dirty="0"/>
-          </a:p>
-        </p:txBody>
-      </p:sp>
-      <p:sp>
-        <p:nvSpPr>
-          <p:cNvPr id="9" name="Text 7"/>
+          <p:cNvPr id="7" name="Text 4"/>
           <p:cNvSpPr/>
           <p:nvPr/>
         </p:nvSpPr>
@@ -3514,7 +3322,7 @@
       </p:sp>
       <p:sp>
         <p:nvSpPr>
-          <p:cNvPr id="10" name="Shape 8"/>
+          <p:cNvPr id="8" name="Shape 5"/>
           <p:cNvSpPr/>
           <p:nvPr/>
         </p:nvSpPr>
@@ -3534,7 +3342,7 @@
       </p:sp>
       <p:sp>
         <p:nvSpPr>
-          <p:cNvPr id="11" name="Text 9"/>
+          <p:cNvPr id="9" name="Text 6"/>
           <p:cNvSpPr/>
           <p:nvPr/>
         </p:nvSpPr>
@@ -3573,7 +3381,7 @@
       </p:sp>
       <p:sp>
         <p:nvSpPr>
-          <p:cNvPr id="12" name="Text 10"/>
+          <p:cNvPr id="10" name="Text 7"/>
           <p:cNvSpPr/>
           <p:nvPr/>
         </p:nvSpPr>
@@ -3612,7 +3420,7 @@
       </p:sp>
       <p:sp>
         <p:nvSpPr>
-          <p:cNvPr id="13" name="Text 11"/>
+          <p:cNvPr id="11" name="Text 8"/>
           <p:cNvSpPr/>
           <p:nvPr/>
         </p:nvSpPr>
@@ -3912,12 +3720,20 @@
           </a:p>
         </p:txBody>
       </p:sp>
-      <p:sp>
-        <p:nvSpPr>
-          <p:cNvPr id="7" name="Shape 5"/>
-          <p:cNvSpPr/>
-          <p:nvPr/>
-        </p:nvSpPr>
+      <p:pic>
+        <p:nvPicPr>
+          <p:cNvPr id="7" name="Image 0" descr="ppt\screens\portfolio_analytics.png">    </p:cNvPr>
+          <p:cNvPicPr>
+            <a:picLocks noChangeAspect="1"/>
+          </p:cNvPicPr>
+          <p:nvPr/>
+        </p:nvPicPr>
+        <p:blipFill>
+          <a:blip r:embed="rId1"/>
+          <a:stretch>
+            <a:fillRect/>
+          </a:stretch>
+        </p:blipFill>
         <p:spPr>
           <a:xfrm>
             <a:off x="457200" y="1691640"/>
@@ -3926,137 +3742,33 @@
           <a:prstGeom prst="rect">
             <a:avLst/>
           </a:prstGeom>
-          <a:solidFill>
-            <a:srgbClr val="F5F7FA"/>
-          </a:solidFill>
-          <a:ln w="19050">
+        </p:spPr>
+      </p:pic>
+      <p:sp>
+        <p:nvSpPr>
+          <p:cNvPr id="8" name="Shape 5"/>
+          <p:cNvSpPr/>
+          <p:nvPr/>
+        </p:nvSpPr>
+        <p:spPr>
+          <a:xfrm>
+            <a:off x="457200" y="1691640"/>
+            <a:ext cx="6858000" cy="4480560"/>
+          </a:xfrm>
+          <a:prstGeom prst="rect">
+            <a:avLst/>
+          </a:prstGeom>
+          <a:ln w="12700">
             <a:solidFill>
               <a:srgbClr val="E1DFDD"/>
             </a:solidFill>
-            <a:prstDash val="dash"/>
+            <a:prstDash val="solid"/>
           </a:ln>
         </p:spPr>
       </p:sp>
       <p:sp>
         <p:nvSpPr>
-          <p:cNvPr id="8" name="Text 6"/>
-          <p:cNvSpPr/>
-          <p:nvPr/>
-        </p:nvSpPr>
-        <p:spPr>
-          <a:xfrm>
-            <a:off x="457200" y="3474720"/>
-            <a:ext cx="6858000" cy="457200"/>
-          </a:xfrm>
-          <a:prstGeom prst="rect">
-            <a:avLst/>
-          </a:prstGeom>
-          <a:noFill/>
-          <a:ln/>
-        </p:spPr>
-        <p:txBody>
-          <a:bodyPr wrap="square" rtlCol="0" anchor="ctr"/>
-          <a:lstStyle/>
-          <a:p>
-            <a:pPr algn="ctr" indent="0" marL="0">
-              <a:buNone/>
-            </a:pPr>
-            <a:r>
-              <a:rPr lang="en-US" sz="1600" b="1" dirty="0">
-                <a:solidFill>
-                  <a:srgbClr val="8A8886"/>
-                </a:solidFill>
-                <a:latin typeface="Segoe UI" pitchFamily="34" charset="0"/>
-                <a:ea typeface="Segoe UI" pitchFamily="34" charset="-122"/>
-                <a:cs typeface="Segoe UI" pitchFamily="34" charset="-120"/>
-              </a:rPr>
-              <a:t>📷  Screenshot</a:t>
-            </a:r>
-            <a:endParaRPr lang="en-US" sz="1600" dirty="0"/>
-          </a:p>
-        </p:txBody>
-      </p:sp>
-      <p:sp>
-        <p:nvSpPr>
-          <p:cNvPr id="9" name="Text 7"/>
-          <p:cNvSpPr/>
-          <p:nvPr/>
-        </p:nvSpPr>
-        <p:spPr>
-          <a:xfrm>
-            <a:off x="731520" y="3977640"/>
-            <a:ext cx="6309360" cy="457200"/>
-          </a:xfrm>
-          <a:prstGeom prst="rect">
-            <a:avLst/>
-          </a:prstGeom>
-          <a:noFill/>
-          <a:ln/>
-        </p:spPr>
-        <p:txBody>
-          <a:bodyPr wrap="square" rtlCol="0" anchor="ctr"/>
-          <a:lstStyle/>
-          <a:p>
-            <a:pPr algn="ctr" indent="0" marL="0">
-              <a:buNone/>
-            </a:pPr>
-            <a:r>
-              <a:rPr lang="en-US" sz="1100" dirty="0">
-                <a:solidFill>
-                  <a:srgbClr val="8A8886"/>
-                </a:solidFill>
-                <a:latin typeface="Segoe UI" pitchFamily="34" charset="0"/>
-                <a:ea typeface="Segoe UI" pitchFamily="34" charset="-122"/>
-                <a:cs typeface="Segoe UI" pitchFamily="34" charset="-120"/>
-              </a:rPr>
-              <a:t>Analytics → Portfolio Analytics → executive band</a:t>
-            </a:r>
-            <a:endParaRPr lang="en-US" sz="1100" dirty="0"/>
-          </a:p>
-        </p:txBody>
-      </p:sp>
-      <p:sp>
-        <p:nvSpPr>
-          <p:cNvPr id="10" name="Text 8"/>
-          <p:cNvSpPr/>
-          <p:nvPr/>
-        </p:nvSpPr>
-        <p:spPr>
-          <a:xfrm>
-            <a:off x="457200" y="5760720"/>
-            <a:ext cx="6858000" cy="320040"/>
-          </a:xfrm>
-          <a:prstGeom prst="rect">
-            <a:avLst/>
-          </a:prstGeom>
-          <a:noFill/>
-          <a:ln/>
-        </p:spPr>
-        <p:txBody>
-          <a:bodyPr wrap="square" rtlCol="0" anchor="ctr"/>
-          <a:lstStyle/>
-          <a:p>
-            <a:pPr algn="ctr" indent="0" marL="0">
-              <a:buNone/>
-            </a:pPr>
-            <a:r>
-              <a:rPr lang="en-US" sz="900" i="1" dirty="0">
-                <a:solidFill>
-                  <a:srgbClr val="8A8886"/>
-                </a:solidFill>
-                <a:latin typeface="Segoe UI" pitchFamily="34" charset="0"/>
-                <a:ea typeface="Segoe UI" pitchFamily="34" charset="-122"/>
-                <a:cs typeface="Segoe UI" pitchFamily="34" charset="-120"/>
-              </a:rPr>
-              <a:t>Paste the live screen capture here</a:t>
-            </a:r>
-            <a:endParaRPr lang="en-US" sz="900" dirty="0"/>
-          </a:p>
-        </p:txBody>
-      </p:sp>
-      <p:sp>
-        <p:nvSpPr>
-          <p:cNvPr id="11" name="Text 9"/>
+          <p:cNvPr id="9" name="Text 6"/>
           <p:cNvSpPr/>
           <p:nvPr/>
         </p:nvSpPr>
@@ -4095,7 +3807,7 @@
       </p:sp>
       <p:sp>
         <p:nvSpPr>
-          <p:cNvPr id="12" name="Shape 10"/>
+          <p:cNvPr id="10" name="Shape 7"/>
           <p:cNvSpPr/>
           <p:nvPr/>
         </p:nvSpPr>
@@ -4115,7 +3827,7 @@
       </p:sp>
       <p:sp>
         <p:nvSpPr>
-          <p:cNvPr id="13" name="Text 11"/>
+          <p:cNvPr id="11" name="Text 8"/>
           <p:cNvSpPr/>
           <p:nvPr/>
         </p:nvSpPr>
@@ -4154,7 +3866,7 @@
       </p:sp>
       <p:sp>
         <p:nvSpPr>
-          <p:cNvPr id="14" name="Text 12"/>
+          <p:cNvPr id="12" name="Text 9"/>
           <p:cNvSpPr/>
           <p:nvPr/>
         </p:nvSpPr>
@@ -4193,7 +3905,7 @@
       </p:sp>
       <p:sp>
         <p:nvSpPr>
-          <p:cNvPr id="15" name="Text 13"/>
+          <p:cNvPr id="13" name="Text 10"/>
           <p:cNvSpPr/>
           <p:nvPr/>
         </p:nvSpPr>
@@ -4493,12 +4205,20 @@
           </a:p>
         </p:txBody>
       </p:sp>
-      <p:sp>
-        <p:nvSpPr>
-          <p:cNvPr id="7" name="Shape 5"/>
-          <p:cNvSpPr/>
-          <p:nvPr/>
-        </p:nvSpPr>
+      <p:pic>
+        <p:nvPicPr>
+          <p:cNvPr id="7" name="Image 0" descr="ppt\screens\kyp.png">    </p:cNvPr>
+          <p:cNvPicPr>
+            <a:picLocks noChangeAspect="1"/>
+          </p:cNvPicPr>
+          <p:nvPr/>
+        </p:nvPicPr>
+        <p:blipFill>
+          <a:blip r:embed="rId1"/>
+          <a:stretch>
+            <a:fillRect/>
+          </a:stretch>
+        </p:blipFill>
         <p:spPr>
           <a:xfrm>
             <a:off x="457200" y="1691640"/>
@@ -4507,137 +4227,33 @@
           <a:prstGeom prst="rect">
             <a:avLst/>
           </a:prstGeom>
-          <a:solidFill>
-            <a:srgbClr val="F5F7FA"/>
-          </a:solidFill>
-          <a:ln w="19050">
+        </p:spPr>
+      </p:pic>
+      <p:sp>
+        <p:nvSpPr>
+          <p:cNvPr id="8" name="Shape 5"/>
+          <p:cNvSpPr/>
+          <p:nvPr/>
+        </p:nvSpPr>
+        <p:spPr>
+          <a:xfrm>
+            <a:off x="457200" y="1691640"/>
+            <a:ext cx="6858000" cy="4480560"/>
+          </a:xfrm>
+          <a:prstGeom prst="rect">
+            <a:avLst/>
+          </a:prstGeom>
+          <a:ln w="12700">
             <a:solidFill>
               <a:srgbClr val="E1DFDD"/>
             </a:solidFill>
-            <a:prstDash val="dash"/>
+            <a:prstDash val="solid"/>
           </a:ln>
         </p:spPr>
       </p:sp>
       <p:sp>
         <p:nvSpPr>
-          <p:cNvPr id="8" name="Text 6"/>
-          <p:cNvSpPr/>
-          <p:nvPr/>
-        </p:nvSpPr>
-        <p:spPr>
-          <a:xfrm>
-            <a:off x="457200" y="3474720"/>
-            <a:ext cx="6858000" cy="457200"/>
-          </a:xfrm>
-          <a:prstGeom prst="rect">
-            <a:avLst/>
-          </a:prstGeom>
-          <a:noFill/>
-          <a:ln/>
-        </p:spPr>
-        <p:txBody>
-          <a:bodyPr wrap="square" rtlCol="0" anchor="ctr"/>
-          <a:lstStyle/>
-          <a:p>
-            <a:pPr algn="ctr" indent="0" marL="0">
-              <a:buNone/>
-            </a:pPr>
-            <a:r>
-              <a:rPr lang="en-US" sz="1600" b="1" dirty="0">
-                <a:solidFill>
-                  <a:srgbClr val="8A8886"/>
-                </a:solidFill>
-                <a:latin typeface="Segoe UI" pitchFamily="34" charset="0"/>
-                <a:ea typeface="Segoe UI" pitchFamily="34" charset="-122"/>
-                <a:cs typeface="Segoe UI" pitchFamily="34" charset="-120"/>
-              </a:rPr>
-              <a:t>📷  Screenshot</a:t>
-            </a:r>
-            <a:endParaRPr lang="en-US" sz="1600" dirty="0"/>
-          </a:p>
-        </p:txBody>
-      </p:sp>
-      <p:sp>
-        <p:nvSpPr>
-          <p:cNvPr id="9" name="Text 7"/>
-          <p:cNvSpPr/>
-          <p:nvPr/>
-        </p:nvSpPr>
-        <p:spPr>
-          <a:xfrm>
-            <a:off x="731520" y="3977640"/>
-            <a:ext cx="6309360" cy="457200"/>
-          </a:xfrm>
-          <a:prstGeom prst="rect">
-            <a:avLst/>
-          </a:prstGeom>
-          <a:noFill/>
-          <a:ln/>
-        </p:spPr>
-        <p:txBody>
-          <a:bodyPr wrap="square" rtlCol="0" anchor="ctr"/>
-          <a:lstStyle/>
-          <a:p>
-            <a:pPr algn="ctr" indent="0" marL="0">
-              <a:buNone/>
-            </a:pPr>
-            <a:r>
-              <a:rPr lang="en-US" sz="1100" dirty="0">
-                <a:solidFill>
-                  <a:srgbClr val="8A8886"/>
-                </a:solidFill>
-                <a:latin typeface="Segoe UI" pitchFamily="34" charset="0"/>
-                <a:ea typeface="Segoe UI" pitchFamily="34" charset="-122"/>
-                <a:cs typeface="Segoe UI" pitchFamily="34" charset="-120"/>
-              </a:rPr>
-              <a:t>Analytics → KYP → Policy / Open &amp; Pending Claim</a:t>
-            </a:r>
-            <a:endParaRPr lang="en-US" sz="1100" dirty="0"/>
-          </a:p>
-        </p:txBody>
-      </p:sp>
-      <p:sp>
-        <p:nvSpPr>
-          <p:cNvPr id="10" name="Text 8"/>
-          <p:cNvSpPr/>
-          <p:nvPr/>
-        </p:nvSpPr>
-        <p:spPr>
-          <a:xfrm>
-            <a:off x="457200" y="5760720"/>
-            <a:ext cx="6858000" cy="320040"/>
-          </a:xfrm>
-          <a:prstGeom prst="rect">
-            <a:avLst/>
-          </a:prstGeom>
-          <a:noFill/>
-          <a:ln/>
-        </p:spPr>
-        <p:txBody>
-          <a:bodyPr wrap="square" rtlCol="0" anchor="ctr"/>
-          <a:lstStyle/>
-          <a:p>
-            <a:pPr algn="ctr" indent="0" marL="0">
-              <a:buNone/>
-            </a:pPr>
-            <a:r>
-              <a:rPr lang="en-US" sz="900" i="1" dirty="0">
-                <a:solidFill>
-                  <a:srgbClr val="8A8886"/>
-                </a:solidFill>
-                <a:latin typeface="Segoe UI" pitchFamily="34" charset="0"/>
-                <a:ea typeface="Segoe UI" pitchFamily="34" charset="-122"/>
-                <a:cs typeface="Segoe UI" pitchFamily="34" charset="-120"/>
-              </a:rPr>
-              <a:t>Paste the live screen capture here</a:t>
-            </a:r>
-            <a:endParaRPr lang="en-US" sz="900" dirty="0"/>
-          </a:p>
-        </p:txBody>
-      </p:sp>
-      <p:sp>
-        <p:nvSpPr>
-          <p:cNvPr id="11" name="Text 9"/>
+          <p:cNvPr id="9" name="Text 6"/>
           <p:cNvSpPr/>
           <p:nvPr/>
         </p:nvSpPr>
@@ -4676,7 +4292,7 @@
       </p:sp>
       <p:sp>
         <p:nvSpPr>
-          <p:cNvPr id="12" name="Shape 10"/>
+          <p:cNvPr id="10" name="Shape 7"/>
           <p:cNvSpPr/>
           <p:nvPr/>
         </p:nvSpPr>
@@ -4696,7 +4312,7 @@
       </p:sp>
       <p:sp>
         <p:nvSpPr>
-          <p:cNvPr id="13" name="Text 11"/>
+          <p:cNvPr id="11" name="Text 8"/>
           <p:cNvSpPr/>
           <p:nvPr/>
         </p:nvSpPr>
@@ -4735,7 +4351,7 @@
       </p:sp>
       <p:sp>
         <p:nvSpPr>
-          <p:cNvPr id="14" name="Text 12"/>
+          <p:cNvPr id="12" name="Text 9"/>
           <p:cNvSpPr/>
           <p:nvPr/>
         </p:nvSpPr>
@@ -4774,7 +4390,7 @@
       </p:sp>
       <p:sp>
         <p:nvSpPr>
-          <p:cNvPr id="15" name="Text 13"/>
+          <p:cNvPr id="13" name="Text 10"/>
           <p:cNvSpPr/>
           <p:nvPr/>
         </p:nvSpPr>
@@ -5074,12 +4690,20 @@
           </a:p>
         </p:txBody>
       </p:sp>
-      <p:sp>
-        <p:nvSpPr>
-          <p:cNvPr id="7" name="Shape 5"/>
-          <p:cNvSpPr/>
-          <p:nvPr/>
-        </p:nvSpPr>
+      <p:pic>
+        <p:nvPicPr>
+          <p:cNvPr id="7" name="Image 0" descr="ppt\screens\assessment_drilldown.png">    </p:cNvPr>
+          <p:cNvPicPr>
+            <a:picLocks noChangeAspect="1"/>
+          </p:cNvPicPr>
+          <p:nvPr/>
+        </p:nvPicPr>
+        <p:blipFill>
+          <a:blip r:embed="rId1"/>
+          <a:stretch>
+            <a:fillRect/>
+          </a:stretch>
+        </p:blipFill>
         <p:spPr>
           <a:xfrm>
             <a:off x="457200" y="1691640"/>
@@ -5088,137 +4712,33 @@
           <a:prstGeom prst="rect">
             <a:avLst/>
           </a:prstGeom>
-          <a:solidFill>
-            <a:srgbClr val="F5F7FA"/>
-          </a:solidFill>
-          <a:ln w="19050">
+        </p:spPr>
+      </p:pic>
+      <p:sp>
+        <p:nvSpPr>
+          <p:cNvPr id="8" name="Shape 5"/>
+          <p:cNvSpPr/>
+          <p:nvPr/>
+        </p:nvSpPr>
+        <p:spPr>
+          <a:xfrm>
+            <a:off x="457200" y="1691640"/>
+            <a:ext cx="6858000" cy="4480560"/>
+          </a:xfrm>
+          <a:prstGeom prst="rect">
+            <a:avLst/>
+          </a:prstGeom>
+          <a:ln w="12700">
             <a:solidFill>
               <a:srgbClr val="E1DFDD"/>
             </a:solidFill>
-            <a:prstDash val="dash"/>
+            <a:prstDash val="solid"/>
           </a:ln>
         </p:spPr>
       </p:sp>
       <p:sp>
         <p:nvSpPr>
-          <p:cNvPr id="8" name="Text 6"/>
-          <p:cNvSpPr/>
-          <p:nvPr/>
-        </p:nvSpPr>
-        <p:spPr>
-          <a:xfrm>
-            <a:off x="457200" y="3474720"/>
-            <a:ext cx="6858000" cy="457200"/>
-          </a:xfrm>
-          <a:prstGeom prst="rect">
-            <a:avLst/>
-          </a:prstGeom>
-          <a:noFill/>
-          <a:ln/>
-        </p:spPr>
-        <p:txBody>
-          <a:bodyPr wrap="square" rtlCol="0" anchor="ctr"/>
-          <a:lstStyle/>
-          <a:p>
-            <a:pPr algn="ctr" indent="0" marL="0">
-              <a:buNone/>
-            </a:pPr>
-            <a:r>
-              <a:rPr lang="en-US" sz="1600" b="1" dirty="0">
-                <a:solidFill>
-                  <a:srgbClr val="8A8886"/>
-                </a:solidFill>
-                <a:latin typeface="Segoe UI" pitchFamily="34" charset="0"/>
-                <a:ea typeface="Segoe UI" pitchFamily="34" charset="-122"/>
-                <a:cs typeface="Segoe UI" pitchFamily="34" charset="-120"/>
-              </a:rPr>
-              <a:t>📷  Screenshot</a:t>
-            </a:r>
-            <a:endParaRPr lang="en-US" sz="1600" dirty="0"/>
-          </a:p>
-        </p:txBody>
-      </p:sp>
-      <p:sp>
-        <p:nvSpPr>
-          <p:cNvPr id="9" name="Text 7"/>
-          <p:cNvSpPr/>
-          <p:nvPr/>
-        </p:nvSpPr>
-        <p:spPr>
-          <a:xfrm>
-            <a:off x="731520" y="3977640"/>
-            <a:ext cx="6309360" cy="457200"/>
-          </a:xfrm>
-          <a:prstGeom prst="rect">
-            <a:avLst/>
-          </a:prstGeom>
-          <a:noFill/>
-          <a:ln/>
-        </p:spPr>
-        <p:txBody>
-          <a:bodyPr wrap="square" rtlCol="0" anchor="ctr"/>
-          <a:lstStyle/>
-          <a:p>
-            <a:pPr algn="ctr" indent="0" marL="0">
-              <a:buNone/>
-            </a:pPr>
-            <a:r>
-              <a:rPr lang="en-US" sz="1100" dirty="0">
-                <a:solidFill>
-                  <a:srgbClr val="8A8886"/>
-                </a:solidFill>
-                <a:latin typeface="Segoe UI" pitchFamily="34" charset="0"/>
-                <a:ea typeface="Segoe UI" pitchFamily="34" charset="-122"/>
-                <a:cs typeface="Segoe UI" pitchFamily="34" charset="-120"/>
-              </a:rPr>
-              <a:t>Analytics → Partnership &amp; Risk → Overall → LTC → Allianz → toggle Risk</a:t>
-            </a:r>
-            <a:endParaRPr lang="en-US" sz="1100" dirty="0"/>
-          </a:p>
-        </p:txBody>
-      </p:sp>
-      <p:sp>
-        <p:nvSpPr>
-          <p:cNvPr id="10" name="Text 8"/>
-          <p:cNvSpPr/>
-          <p:nvPr/>
-        </p:nvSpPr>
-        <p:spPr>
-          <a:xfrm>
-            <a:off x="457200" y="5760720"/>
-            <a:ext cx="6858000" cy="320040"/>
-          </a:xfrm>
-          <a:prstGeom prst="rect">
-            <a:avLst/>
-          </a:prstGeom>
-          <a:noFill/>
-          <a:ln/>
-        </p:spPr>
-        <p:txBody>
-          <a:bodyPr wrap="square" rtlCol="0" anchor="ctr"/>
-          <a:lstStyle/>
-          <a:p>
-            <a:pPr algn="ctr" indent="0" marL="0">
-              <a:buNone/>
-            </a:pPr>
-            <a:r>
-              <a:rPr lang="en-US" sz="900" i="1" dirty="0">
-                <a:solidFill>
-                  <a:srgbClr val="8A8886"/>
-                </a:solidFill>
-                <a:latin typeface="Segoe UI" pitchFamily="34" charset="0"/>
-                <a:ea typeface="Segoe UI" pitchFamily="34" charset="-122"/>
-                <a:cs typeface="Segoe UI" pitchFamily="34" charset="-120"/>
-              </a:rPr>
-              <a:t>Paste the live screen capture here</a:t>
-            </a:r>
-            <a:endParaRPr lang="en-US" sz="900" dirty="0"/>
-          </a:p>
-        </p:txBody>
-      </p:sp>
-      <p:sp>
-        <p:nvSpPr>
-          <p:cNvPr id="11" name="Text 9"/>
+          <p:cNvPr id="9" name="Text 6"/>
           <p:cNvSpPr/>
           <p:nvPr/>
         </p:nvSpPr>
@@ -5257,7 +4777,7 @@
       </p:sp>
       <p:sp>
         <p:nvSpPr>
-          <p:cNvPr id="12" name="Shape 10"/>
+          <p:cNvPr id="10" name="Shape 7"/>
           <p:cNvSpPr/>
           <p:nvPr/>
         </p:nvSpPr>
@@ -5277,7 +4797,7 @@
       </p:sp>
       <p:sp>
         <p:nvSpPr>
-          <p:cNvPr id="13" name="Text 11"/>
+          <p:cNvPr id="11" name="Text 8"/>
           <p:cNvSpPr/>
           <p:nvPr/>
         </p:nvSpPr>
@@ -5316,7 +4836,7 @@
       </p:sp>
       <p:sp>
         <p:nvSpPr>
-          <p:cNvPr id="14" name="Text 12"/>
+          <p:cNvPr id="12" name="Text 9"/>
           <p:cNvSpPr/>
           <p:nvPr/>
         </p:nvSpPr>
@@ -5355,7 +4875,7 @@
       </p:sp>
       <p:sp>
         <p:nvSpPr>
-          <p:cNvPr id="15" name="Text 13"/>
+          <p:cNvPr id="13" name="Text 10"/>
           <p:cNvSpPr/>
           <p:nvPr/>
         </p:nvSpPr>
@@ -5655,12 +5175,20 @@
           </a:p>
         </p:txBody>
       </p:sp>
-      <p:sp>
-        <p:nvSpPr>
-          <p:cNvPr id="7" name="Shape 5"/>
-          <p:cNvSpPr/>
-          <p:nvPr/>
-        </p:nvSpPr>
+      <p:pic>
+        <p:nvPicPr>
+          <p:cNvPr id="7" name="Image 0" descr="ppt\screens\external_links.png">    </p:cNvPr>
+          <p:cNvPicPr>
+            <a:picLocks noChangeAspect="1"/>
+          </p:cNvPicPr>
+          <p:nvPr/>
+        </p:nvPicPr>
+        <p:blipFill>
+          <a:blip r:embed="rId1"/>
+          <a:stretch>
+            <a:fillRect/>
+          </a:stretch>
+        </p:blipFill>
         <p:spPr>
           <a:xfrm>
             <a:off x="457200" y="1691640"/>
@@ -5669,137 +5197,33 @@
           <a:prstGeom prst="rect">
             <a:avLst/>
           </a:prstGeom>
-          <a:solidFill>
-            <a:srgbClr val="F5F7FA"/>
-          </a:solidFill>
-          <a:ln w="19050">
+        </p:spPr>
+      </p:pic>
+      <p:sp>
+        <p:nvSpPr>
+          <p:cNvPr id="8" name="Shape 5"/>
+          <p:cNvSpPr/>
+          <p:nvPr/>
+        </p:nvSpPr>
+        <p:spPr>
+          <a:xfrm>
+            <a:off x="457200" y="1691640"/>
+            <a:ext cx="6858000" cy="4480560"/>
+          </a:xfrm>
+          <a:prstGeom prst="rect">
+            <a:avLst/>
+          </a:prstGeom>
+          <a:ln w="12700">
             <a:solidFill>
               <a:srgbClr val="E1DFDD"/>
             </a:solidFill>
-            <a:prstDash val="dash"/>
+            <a:prstDash val="solid"/>
           </a:ln>
         </p:spPr>
       </p:sp>
       <p:sp>
         <p:nvSpPr>
-          <p:cNvPr id="8" name="Text 6"/>
-          <p:cNvSpPr/>
-          <p:nvPr/>
-        </p:nvSpPr>
-        <p:spPr>
-          <a:xfrm>
-            <a:off x="457200" y="3474720"/>
-            <a:ext cx="6858000" cy="457200"/>
-          </a:xfrm>
-          <a:prstGeom prst="rect">
-            <a:avLst/>
-          </a:prstGeom>
-          <a:noFill/>
-          <a:ln/>
-        </p:spPr>
-        <p:txBody>
-          <a:bodyPr wrap="square" rtlCol="0" anchor="ctr"/>
-          <a:lstStyle/>
-          <a:p>
-            <a:pPr algn="ctr" indent="0" marL="0">
-              <a:buNone/>
-            </a:pPr>
-            <a:r>
-              <a:rPr lang="en-US" sz="1600" b="1" dirty="0">
-                <a:solidFill>
-                  <a:srgbClr val="8A8886"/>
-                </a:solidFill>
-                <a:latin typeface="Segoe UI" pitchFamily="34" charset="0"/>
-                <a:ea typeface="Segoe UI" pitchFamily="34" charset="-122"/>
-                <a:cs typeface="Segoe UI" pitchFamily="34" charset="-120"/>
-              </a:rPr>
-              <a:t>📷  Screenshot</a:t>
-            </a:r>
-            <a:endParaRPr lang="en-US" sz="1600" dirty="0"/>
-          </a:p>
-        </p:txBody>
-      </p:sp>
-      <p:sp>
-        <p:nvSpPr>
-          <p:cNvPr id="9" name="Text 7"/>
-          <p:cNvSpPr/>
-          <p:nvPr/>
-        </p:nvSpPr>
-        <p:spPr>
-          <a:xfrm>
-            <a:off x="731520" y="3977640"/>
-            <a:ext cx="6309360" cy="457200"/>
-          </a:xfrm>
-          <a:prstGeom prst="rect">
-            <a:avLst/>
-          </a:prstGeom>
-          <a:noFill/>
-          <a:ln/>
-        </p:spPr>
-        <p:txBody>
-          <a:bodyPr wrap="square" rtlCol="0" anchor="ctr"/>
-          <a:lstStyle/>
-          <a:p>
-            <a:pPr algn="ctr" indent="0" marL="0">
-              <a:buNone/>
-            </a:pPr>
-            <a:r>
-              <a:rPr lang="en-US" sz="1100" dirty="0">
-                <a:solidFill>
-                  <a:srgbClr val="8A8886"/>
-                </a:solidFill>
-                <a:latin typeface="Segoe UI" pitchFamily="34" charset="0"/>
-                <a:ea typeface="Segoe UI" pitchFamily="34" charset="-122"/>
-                <a:cs typeface="Segoe UI" pitchFamily="34" charset="-120"/>
-              </a:rPr>
-              <a:t>Cedents &amp; Contacts → External Systems  ·  Help &amp; Resources → Help</a:t>
-            </a:r>
-            <a:endParaRPr lang="en-US" sz="1100" dirty="0"/>
-          </a:p>
-        </p:txBody>
-      </p:sp>
-      <p:sp>
-        <p:nvSpPr>
-          <p:cNvPr id="10" name="Text 8"/>
-          <p:cNvSpPr/>
-          <p:nvPr/>
-        </p:nvSpPr>
-        <p:spPr>
-          <a:xfrm>
-            <a:off x="457200" y="5760720"/>
-            <a:ext cx="6858000" cy="320040"/>
-          </a:xfrm>
-          <a:prstGeom prst="rect">
-            <a:avLst/>
-          </a:prstGeom>
-          <a:noFill/>
-          <a:ln/>
-        </p:spPr>
-        <p:txBody>
-          <a:bodyPr wrap="square" rtlCol="0" anchor="ctr"/>
-          <a:lstStyle/>
-          <a:p>
-            <a:pPr algn="ctr" indent="0" marL="0">
-              <a:buNone/>
-            </a:pPr>
-            <a:r>
-              <a:rPr lang="en-US" sz="900" i="1" dirty="0">
-                <a:solidFill>
-                  <a:srgbClr val="8A8886"/>
-                </a:solidFill>
-                <a:latin typeface="Segoe UI" pitchFamily="34" charset="0"/>
-                <a:ea typeface="Segoe UI" pitchFamily="34" charset="-122"/>
-                <a:cs typeface="Segoe UI" pitchFamily="34" charset="-120"/>
-              </a:rPr>
-              <a:t>Paste the live screen capture here</a:t>
-            </a:r>
-            <a:endParaRPr lang="en-US" sz="900" dirty="0"/>
-          </a:p>
-        </p:txBody>
-      </p:sp>
-      <p:sp>
-        <p:nvSpPr>
-          <p:cNvPr id="11" name="Text 9"/>
+          <p:cNvPr id="9" name="Text 6"/>
           <p:cNvSpPr/>
           <p:nvPr/>
         </p:nvSpPr>
@@ -5838,7 +5262,7 @@
       </p:sp>
       <p:sp>
         <p:nvSpPr>
-          <p:cNvPr id="12" name="Shape 10"/>
+          <p:cNvPr id="10" name="Shape 7"/>
           <p:cNvSpPr/>
           <p:nvPr/>
         </p:nvSpPr>
@@ -5858,7 +5282,7 @@
       </p:sp>
       <p:sp>
         <p:nvSpPr>
-          <p:cNvPr id="13" name="Text 11"/>
+          <p:cNvPr id="11" name="Text 8"/>
           <p:cNvSpPr/>
           <p:nvPr/>
         </p:nvSpPr>
@@ -5897,7 +5321,7 @@
       </p:sp>
       <p:sp>
         <p:nvSpPr>
-          <p:cNvPr id="14" name="Text 12"/>
+          <p:cNvPr id="12" name="Text 9"/>
           <p:cNvSpPr/>
           <p:nvPr/>
         </p:nvSpPr>
@@ -5936,7 +5360,7 @@
       </p:sp>
       <p:sp>
         <p:nvSpPr>
-          <p:cNvPr id="15" name="Text 13"/>
+          <p:cNvPr id="13" name="Text 10"/>
           <p:cNvSpPr/>
           <p:nvPr/>
         </p:nvSpPr>
@@ -8111,12 +7535,20 @@
           </a:p>
         </p:txBody>
       </p:sp>
-      <p:sp>
-        <p:nvSpPr>
-          <p:cNvPr id="7" name="Shape 5"/>
-          <p:cNvSpPr/>
-          <p:nvPr/>
-        </p:nvSpPr>
+      <p:pic>
+        <p:nvPicPr>
+          <p:cNvPr id="7" name="Image 0" descr="ppt\screens\relationship_map.png">    </p:cNvPr>
+          <p:cNvPicPr>
+            <a:picLocks noChangeAspect="1"/>
+          </p:cNvPicPr>
+          <p:nvPr/>
+        </p:nvPicPr>
+        <p:blipFill>
+          <a:blip r:embed="rId1"/>
+          <a:stretch>
+            <a:fillRect/>
+          </a:stretch>
+        </p:blipFill>
         <p:spPr>
           <a:xfrm>
             <a:off x="457200" y="1691640"/>
@@ -8125,137 +7557,33 @@
           <a:prstGeom prst="rect">
             <a:avLst/>
           </a:prstGeom>
-          <a:solidFill>
-            <a:srgbClr val="F5F7FA"/>
-          </a:solidFill>
-          <a:ln w="19050">
+        </p:spPr>
+      </p:pic>
+      <p:sp>
+        <p:nvSpPr>
+          <p:cNvPr id="8" name="Shape 5"/>
+          <p:cNvSpPr/>
+          <p:nvPr/>
+        </p:nvSpPr>
+        <p:spPr>
+          <a:xfrm>
+            <a:off x="457200" y="1691640"/>
+            <a:ext cx="6858000" cy="4480560"/>
+          </a:xfrm>
+          <a:prstGeom prst="rect">
+            <a:avLst/>
+          </a:prstGeom>
+          <a:ln w="12700">
             <a:solidFill>
               <a:srgbClr val="E1DFDD"/>
             </a:solidFill>
-            <a:prstDash val="dash"/>
+            <a:prstDash val="solid"/>
           </a:ln>
         </p:spPr>
       </p:sp>
       <p:sp>
         <p:nvSpPr>
-          <p:cNvPr id="8" name="Text 6"/>
-          <p:cNvSpPr/>
-          <p:nvPr/>
-        </p:nvSpPr>
-        <p:spPr>
-          <a:xfrm>
-            <a:off x="457200" y="3474720"/>
-            <a:ext cx="6858000" cy="457200"/>
-          </a:xfrm>
-          <a:prstGeom prst="rect">
-            <a:avLst/>
-          </a:prstGeom>
-          <a:noFill/>
-          <a:ln/>
-        </p:spPr>
-        <p:txBody>
-          <a:bodyPr wrap="square" rtlCol="0" anchor="ctr"/>
-          <a:lstStyle/>
-          <a:p>
-            <a:pPr algn="ctr" indent="0" marL="0">
-              <a:buNone/>
-            </a:pPr>
-            <a:r>
-              <a:rPr lang="en-US" sz="1600" b="1" dirty="0">
-                <a:solidFill>
-                  <a:srgbClr val="8A8886"/>
-                </a:solidFill>
-                <a:latin typeface="Segoe UI" pitchFamily="34" charset="0"/>
-                <a:ea typeface="Segoe UI" pitchFamily="34" charset="-122"/>
-                <a:cs typeface="Segoe UI" pitchFamily="34" charset="-120"/>
-              </a:rPr>
-              <a:t>📷  Screenshot</a:t>
-            </a:r>
-            <a:endParaRPr lang="en-US" sz="1600" dirty="0"/>
-          </a:p>
-        </p:txBody>
-      </p:sp>
-      <p:sp>
-        <p:nvSpPr>
-          <p:cNvPr id="9" name="Text 7"/>
-          <p:cNvSpPr/>
-          <p:nvPr/>
-        </p:nvSpPr>
-        <p:spPr>
-          <a:xfrm>
-            <a:off x="731520" y="3977640"/>
-            <a:ext cx="6309360" cy="457200"/>
-          </a:xfrm>
-          <a:prstGeom prst="rect">
-            <a:avLst/>
-          </a:prstGeom>
-          <a:noFill/>
-          <a:ln/>
-        </p:spPr>
-        <p:txBody>
-          <a:bodyPr wrap="square" rtlCol="0" anchor="ctr"/>
-          <a:lstStyle/>
-          <a:p>
-            <a:pPr algn="ctr" indent="0" marL="0">
-              <a:buNone/>
-            </a:pPr>
-            <a:r>
-              <a:rPr lang="en-US" sz="1100" dirty="0">
-                <a:solidFill>
-                  <a:srgbClr val="8A8886"/>
-                </a:solidFill>
-                <a:latin typeface="Segoe UI" pitchFamily="34" charset="0"/>
-                <a:ea typeface="Segoe UI" pitchFamily="34" charset="-122"/>
-                <a:cs typeface="Segoe UI" pitchFamily="34" charset="-120"/>
-              </a:rPr>
-              <a:t>Cedents &amp; Contacts → Relationship Map</a:t>
-            </a:r>
-            <a:endParaRPr lang="en-US" sz="1100" dirty="0"/>
-          </a:p>
-        </p:txBody>
-      </p:sp>
-      <p:sp>
-        <p:nvSpPr>
-          <p:cNvPr id="10" name="Text 8"/>
-          <p:cNvSpPr/>
-          <p:nvPr/>
-        </p:nvSpPr>
-        <p:spPr>
-          <a:xfrm>
-            <a:off x="457200" y="5760720"/>
-            <a:ext cx="6858000" cy="320040"/>
-          </a:xfrm>
-          <a:prstGeom prst="rect">
-            <a:avLst/>
-          </a:prstGeom>
-          <a:noFill/>
-          <a:ln/>
-        </p:spPr>
-        <p:txBody>
-          <a:bodyPr wrap="square" rtlCol="0" anchor="ctr"/>
-          <a:lstStyle/>
-          <a:p>
-            <a:pPr algn="ctr" indent="0" marL="0">
-              <a:buNone/>
-            </a:pPr>
-            <a:r>
-              <a:rPr lang="en-US" sz="900" i="1" dirty="0">
-                <a:solidFill>
-                  <a:srgbClr val="8A8886"/>
-                </a:solidFill>
-                <a:latin typeface="Segoe UI" pitchFamily="34" charset="0"/>
-                <a:ea typeface="Segoe UI" pitchFamily="34" charset="-122"/>
-                <a:cs typeface="Segoe UI" pitchFamily="34" charset="-120"/>
-              </a:rPr>
-              <a:t>Paste the live screen capture here</a:t>
-            </a:r>
-            <a:endParaRPr lang="en-US" sz="900" dirty="0"/>
-          </a:p>
-        </p:txBody>
-      </p:sp>
-      <p:sp>
-        <p:nvSpPr>
-          <p:cNvPr id="11" name="Text 9"/>
+          <p:cNvPr id="9" name="Text 6"/>
           <p:cNvSpPr/>
           <p:nvPr/>
         </p:nvSpPr>
@@ -8294,7 +7622,7 @@
       </p:sp>
       <p:sp>
         <p:nvSpPr>
-          <p:cNvPr id="12" name="Shape 10"/>
+          <p:cNvPr id="10" name="Shape 7"/>
           <p:cNvSpPr/>
           <p:nvPr/>
         </p:nvSpPr>
@@ -8314,7 +7642,7 @@
       </p:sp>
       <p:sp>
         <p:nvSpPr>
-          <p:cNvPr id="13" name="Text 11"/>
+          <p:cNvPr id="11" name="Text 8"/>
           <p:cNvSpPr/>
           <p:nvPr/>
         </p:nvSpPr>
@@ -8353,7 +7681,7 @@
       </p:sp>
       <p:sp>
         <p:nvSpPr>
-          <p:cNvPr id="14" name="Text 12"/>
+          <p:cNvPr id="12" name="Text 9"/>
           <p:cNvSpPr/>
           <p:nvPr/>
         </p:nvSpPr>
@@ -8392,7 +7720,7 @@
       </p:sp>
       <p:sp>
         <p:nvSpPr>
-          <p:cNvPr id="15" name="Text 13"/>
+          <p:cNvPr id="13" name="Text 10"/>
           <p:cNvSpPr/>
           <p:nvPr/>
         </p:nvSpPr>
@@ -8631,12 +7959,20 @@
           </a:p>
         </p:txBody>
       </p:sp>
-      <p:sp>
-        <p:nvSpPr>
-          <p:cNvPr id="5" name="Shape 3"/>
-          <p:cNvSpPr/>
-          <p:nvPr/>
-        </p:nvSpPr>
+      <p:pic>
+        <p:nvPicPr>
+          <p:cNvPr id="5" name="Image 0" descr="ppt\screens\relationship_map.png">    </p:cNvPr>
+          <p:cNvPicPr>
+            <a:picLocks noChangeAspect="1"/>
+          </p:cNvPicPr>
+          <p:nvPr/>
+        </p:nvPicPr>
+        <p:blipFill>
+          <a:blip r:embed="rId1"/>
+          <a:stretch>
+            <a:fillRect/>
+          </a:stretch>
+        </p:blipFill>
         <p:spPr>
           <a:xfrm>
             <a:off x="457200" y="1691640"/>
@@ -8645,137 +7981,33 @@
           <a:prstGeom prst="rect">
             <a:avLst/>
           </a:prstGeom>
-          <a:solidFill>
-            <a:srgbClr val="F5F7FA"/>
-          </a:solidFill>
-          <a:ln w="19050">
+        </p:spPr>
+      </p:pic>
+      <p:sp>
+        <p:nvSpPr>
+          <p:cNvPr id="6" name="Shape 3"/>
+          <p:cNvSpPr/>
+          <p:nvPr/>
+        </p:nvSpPr>
+        <p:spPr>
+          <a:xfrm>
+            <a:off x="457200" y="1691640"/>
+            <a:ext cx="6858000" cy="4480560"/>
+          </a:xfrm>
+          <a:prstGeom prst="rect">
+            <a:avLst/>
+          </a:prstGeom>
+          <a:ln w="12700">
             <a:solidFill>
               <a:srgbClr val="E1DFDD"/>
             </a:solidFill>
-            <a:prstDash val="dash"/>
+            <a:prstDash val="solid"/>
           </a:ln>
         </p:spPr>
       </p:sp>
       <p:sp>
         <p:nvSpPr>
-          <p:cNvPr id="6" name="Text 4"/>
-          <p:cNvSpPr/>
-          <p:nvPr/>
-        </p:nvSpPr>
-        <p:spPr>
-          <a:xfrm>
-            <a:off x="457200" y="3474720"/>
-            <a:ext cx="6858000" cy="457200"/>
-          </a:xfrm>
-          <a:prstGeom prst="rect">
-            <a:avLst/>
-          </a:prstGeom>
-          <a:noFill/>
-          <a:ln/>
-        </p:spPr>
-        <p:txBody>
-          <a:bodyPr wrap="square" rtlCol="0" anchor="ctr"/>
-          <a:lstStyle/>
-          <a:p>
-            <a:pPr algn="ctr" indent="0" marL="0">
-              <a:buNone/>
-            </a:pPr>
-            <a:r>
-              <a:rPr lang="en-US" sz="1600" b="1" dirty="0">
-                <a:solidFill>
-                  <a:srgbClr val="8A8886"/>
-                </a:solidFill>
-                <a:latin typeface="Segoe UI" pitchFamily="34" charset="0"/>
-                <a:ea typeface="Segoe UI" pitchFamily="34" charset="-122"/>
-                <a:cs typeface="Segoe UI" pitchFamily="34" charset="-120"/>
-              </a:rPr>
-              <a:t>📷  Screenshot</a:t>
-            </a:r>
-            <a:endParaRPr lang="en-US" sz="1600" dirty="0"/>
-          </a:p>
-        </p:txBody>
-      </p:sp>
-      <p:sp>
-        <p:nvSpPr>
-          <p:cNvPr id="7" name="Text 5"/>
-          <p:cNvSpPr/>
-          <p:nvPr/>
-        </p:nvSpPr>
-        <p:spPr>
-          <a:xfrm>
-            <a:off x="731520" y="3977640"/>
-            <a:ext cx="6309360" cy="457200"/>
-          </a:xfrm>
-          <a:prstGeom prst="rect">
-            <a:avLst/>
-          </a:prstGeom>
-          <a:noFill/>
-          <a:ln/>
-        </p:spPr>
-        <p:txBody>
-          <a:bodyPr wrap="square" rtlCol="0" anchor="ctr"/>
-          <a:lstStyle/>
-          <a:p>
-            <a:pPr algn="ctr" indent="0" marL="0">
-              <a:buNone/>
-            </a:pPr>
-            <a:r>
-              <a:rPr lang="en-US" sz="1100" dirty="0">
-                <a:solidFill>
-                  <a:srgbClr val="8A8886"/>
-                </a:solidFill>
-                <a:latin typeface="Segoe UI" pitchFamily="34" charset="0"/>
-                <a:ea typeface="Segoe UI" pitchFamily="34" charset="-122"/>
-                <a:cs typeface="Segoe UI" pitchFamily="34" charset="-120"/>
-              </a:rPr>
-              <a:t>Relationship Map → Coverage Matrix → filter ERAC / Illumifin</a:t>
-            </a:r>
-            <a:endParaRPr lang="en-US" sz="1100" dirty="0"/>
-          </a:p>
-        </p:txBody>
-      </p:sp>
-      <p:sp>
-        <p:nvSpPr>
-          <p:cNvPr id="8" name="Text 6"/>
-          <p:cNvSpPr/>
-          <p:nvPr/>
-        </p:nvSpPr>
-        <p:spPr>
-          <a:xfrm>
-            <a:off x="457200" y="5760720"/>
-            <a:ext cx="6858000" cy="320040"/>
-          </a:xfrm>
-          <a:prstGeom prst="rect">
-            <a:avLst/>
-          </a:prstGeom>
-          <a:noFill/>
-          <a:ln/>
-        </p:spPr>
-        <p:txBody>
-          <a:bodyPr wrap="square" rtlCol="0" anchor="ctr"/>
-          <a:lstStyle/>
-          <a:p>
-            <a:pPr algn="ctr" indent="0" marL="0">
-              <a:buNone/>
-            </a:pPr>
-            <a:r>
-              <a:rPr lang="en-US" sz="900" i="1" dirty="0">
-                <a:solidFill>
-                  <a:srgbClr val="8A8886"/>
-                </a:solidFill>
-                <a:latin typeface="Segoe UI" pitchFamily="34" charset="0"/>
-                <a:ea typeface="Segoe UI" pitchFamily="34" charset="-122"/>
-                <a:cs typeface="Segoe UI" pitchFamily="34" charset="-120"/>
-              </a:rPr>
-              <a:t>Paste the live screen capture here</a:t>
-            </a:r>
-            <a:endParaRPr lang="en-US" sz="900" dirty="0"/>
-          </a:p>
-        </p:txBody>
-      </p:sp>
-      <p:sp>
-        <p:nvSpPr>
-          <p:cNvPr id="9" name="Text 7"/>
+          <p:cNvPr id="7" name="Text 4"/>
           <p:cNvSpPr/>
           <p:nvPr/>
         </p:nvSpPr>
@@ -8814,7 +8046,7 @@
       </p:sp>
       <p:sp>
         <p:nvSpPr>
-          <p:cNvPr id="10" name="Shape 8"/>
+          <p:cNvPr id="8" name="Shape 5"/>
           <p:cNvSpPr/>
           <p:nvPr/>
         </p:nvSpPr>
@@ -8834,7 +8066,7 @@
       </p:sp>
       <p:sp>
         <p:nvSpPr>
-          <p:cNvPr id="11" name="Text 9"/>
+          <p:cNvPr id="9" name="Text 6"/>
           <p:cNvSpPr/>
           <p:nvPr/>
         </p:nvSpPr>
@@ -8873,7 +8105,7 @@
       </p:sp>
       <p:sp>
         <p:nvSpPr>
-          <p:cNvPr id="12" name="Text 10"/>
+          <p:cNvPr id="10" name="Text 7"/>
           <p:cNvSpPr/>
           <p:nvPr/>
         </p:nvSpPr>
@@ -8912,7 +8144,7 @@
       </p:sp>
       <p:sp>
         <p:nvSpPr>
-          <p:cNvPr id="13" name="Text 11"/>
+          <p:cNvPr id="11" name="Text 8"/>
           <p:cNvSpPr/>
           <p:nvPr/>
         </p:nvSpPr>
@@ -9212,12 +8444,20 @@
           </a:p>
         </p:txBody>
       </p:sp>
-      <p:sp>
-        <p:nvSpPr>
-          <p:cNvPr id="7" name="Shape 5"/>
-          <p:cNvSpPr/>
-          <p:nvPr/>
-        </p:nvSpPr>
+      <p:pic>
+        <p:nvPicPr>
+          <p:cNvPr id="7" name="Image 0" descr="ppt\screens\cedent_360.png">    </p:cNvPr>
+          <p:cNvPicPr>
+            <a:picLocks noChangeAspect="1"/>
+          </p:cNvPicPr>
+          <p:nvPr/>
+        </p:nvPicPr>
+        <p:blipFill>
+          <a:blip r:embed="rId1"/>
+          <a:stretch>
+            <a:fillRect/>
+          </a:stretch>
+        </p:blipFill>
         <p:spPr>
           <a:xfrm>
             <a:off x="457200" y="1691640"/>
@@ -9226,137 +8466,33 @@
           <a:prstGeom prst="rect">
             <a:avLst/>
           </a:prstGeom>
-          <a:solidFill>
-            <a:srgbClr val="F5F7FA"/>
-          </a:solidFill>
-          <a:ln w="19050">
+        </p:spPr>
+      </p:pic>
+      <p:sp>
+        <p:nvSpPr>
+          <p:cNvPr id="8" name="Shape 5"/>
+          <p:cNvSpPr/>
+          <p:nvPr/>
+        </p:nvSpPr>
+        <p:spPr>
+          <a:xfrm>
+            <a:off x="457200" y="1691640"/>
+            <a:ext cx="6858000" cy="4480560"/>
+          </a:xfrm>
+          <a:prstGeom prst="rect">
+            <a:avLst/>
+          </a:prstGeom>
+          <a:ln w="12700">
             <a:solidFill>
               <a:srgbClr val="E1DFDD"/>
             </a:solidFill>
-            <a:prstDash val="dash"/>
+            <a:prstDash val="solid"/>
           </a:ln>
         </p:spPr>
       </p:sp>
       <p:sp>
         <p:nvSpPr>
-          <p:cNvPr id="8" name="Text 6"/>
-          <p:cNvSpPr/>
-          <p:nvPr/>
-        </p:nvSpPr>
-        <p:spPr>
-          <a:xfrm>
-            <a:off x="457200" y="3474720"/>
-            <a:ext cx="6858000" cy="457200"/>
-          </a:xfrm>
-          <a:prstGeom prst="rect">
-            <a:avLst/>
-          </a:prstGeom>
-          <a:noFill/>
-          <a:ln/>
-        </p:spPr>
-        <p:txBody>
-          <a:bodyPr wrap="square" rtlCol="0" anchor="ctr"/>
-          <a:lstStyle/>
-          <a:p>
-            <a:pPr algn="ctr" indent="0" marL="0">
-              <a:buNone/>
-            </a:pPr>
-            <a:r>
-              <a:rPr lang="en-US" sz="1600" b="1" dirty="0">
-                <a:solidFill>
-                  <a:srgbClr val="8A8886"/>
-                </a:solidFill>
-                <a:latin typeface="Segoe UI" pitchFamily="34" charset="0"/>
-                <a:ea typeface="Segoe UI" pitchFamily="34" charset="-122"/>
-                <a:cs typeface="Segoe UI" pitchFamily="34" charset="-120"/>
-              </a:rPr>
-              <a:t>📷  Screenshot</a:t>
-            </a:r>
-            <a:endParaRPr lang="en-US" sz="1600" dirty="0"/>
-          </a:p>
-        </p:txBody>
-      </p:sp>
-      <p:sp>
-        <p:nvSpPr>
-          <p:cNvPr id="9" name="Text 7"/>
-          <p:cNvSpPr/>
-          <p:nvPr/>
-        </p:nvSpPr>
-        <p:spPr>
-          <a:xfrm>
-            <a:off x="731520" y="3977640"/>
-            <a:ext cx="6309360" cy="457200"/>
-          </a:xfrm>
-          <a:prstGeom prst="rect">
-            <a:avLst/>
-          </a:prstGeom>
-          <a:noFill/>
-          <a:ln/>
-        </p:spPr>
-        <p:txBody>
-          <a:bodyPr wrap="square" rtlCol="0" anchor="ctr"/>
-          <a:lstStyle/>
-          <a:p>
-            <a:pPr algn="ctr" indent="0" marL="0">
-              <a:buNone/>
-            </a:pPr>
-            <a:r>
-              <a:rPr lang="en-US" sz="1100" dirty="0">
-                <a:solidFill>
-                  <a:srgbClr val="8A8886"/>
-                </a:solidFill>
-                <a:latin typeface="Segoe UI" pitchFamily="34" charset="0"/>
-                <a:ea typeface="Segoe UI" pitchFamily="34" charset="-122"/>
-                <a:cs typeface="Segoe UI" pitchFamily="34" charset="-120"/>
-              </a:rPr>
-              <a:t>Partner Views → Cedents → Allianz → Summary</a:t>
-            </a:r>
-            <a:endParaRPr lang="en-US" sz="1100" dirty="0"/>
-          </a:p>
-        </p:txBody>
-      </p:sp>
-      <p:sp>
-        <p:nvSpPr>
-          <p:cNvPr id="10" name="Text 8"/>
-          <p:cNvSpPr/>
-          <p:nvPr/>
-        </p:nvSpPr>
-        <p:spPr>
-          <a:xfrm>
-            <a:off x="457200" y="5760720"/>
-            <a:ext cx="6858000" cy="320040"/>
-          </a:xfrm>
-          <a:prstGeom prst="rect">
-            <a:avLst/>
-          </a:prstGeom>
-          <a:noFill/>
-          <a:ln/>
-        </p:spPr>
-        <p:txBody>
-          <a:bodyPr wrap="square" rtlCol="0" anchor="ctr"/>
-          <a:lstStyle/>
-          <a:p>
-            <a:pPr algn="ctr" indent="0" marL="0">
-              <a:buNone/>
-            </a:pPr>
-            <a:r>
-              <a:rPr lang="en-US" sz="900" i="1" dirty="0">
-                <a:solidFill>
-                  <a:srgbClr val="8A8886"/>
-                </a:solidFill>
-                <a:latin typeface="Segoe UI" pitchFamily="34" charset="0"/>
-                <a:ea typeface="Segoe UI" pitchFamily="34" charset="-122"/>
-                <a:cs typeface="Segoe UI" pitchFamily="34" charset="-120"/>
-              </a:rPr>
-              <a:t>Paste the live screen capture here</a:t>
-            </a:r>
-            <a:endParaRPr lang="en-US" sz="900" dirty="0"/>
-          </a:p>
-        </p:txBody>
-      </p:sp>
-      <p:sp>
-        <p:nvSpPr>
-          <p:cNvPr id="11" name="Text 9"/>
+          <p:cNvPr id="9" name="Text 6"/>
           <p:cNvSpPr/>
           <p:nvPr/>
         </p:nvSpPr>
@@ -9395,7 +8531,7 @@
       </p:sp>
       <p:sp>
         <p:nvSpPr>
-          <p:cNvPr id="12" name="Shape 10"/>
+          <p:cNvPr id="10" name="Shape 7"/>
           <p:cNvSpPr/>
           <p:nvPr/>
         </p:nvSpPr>
@@ -9415,7 +8551,7 @@
       </p:sp>
       <p:sp>
         <p:nvSpPr>
-          <p:cNvPr id="13" name="Text 11"/>
+          <p:cNvPr id="11" name="Text 8"/>
           <p:cNvSpPr/>
           <p:nvPr/>
         </p:nvSpPr>
@@ -9454,7 +8590,7 @@
       </p:sp>
       <p:sp>
         <p:nvSpPr>
-          <p:cNvPr id="14" name="Text 12"/>
+          <p:cNvPr id="12" name="Text 9"/>
           <p:cNvSpPr/>
           <p:nvPr/>
         </p:nvSpPr>
@@ -9493,7 +8629,7 @@
       </p:sp>
       <p:sp>
         <p:nvSpPr>
-          <p:cNvPr id="15" name="Text 13"/>
+          <p:cNvPr id="13" name="Text 10"/>
           <p:cNvSpPr/>
           <p:nvPr/>
         </p:nvSpPr>
@@ -9793,12 +8929,20 @@
           </a:p>
         </p:txBody>
       </p:sp>
-      <p:sp>
-        <p:nvSpPr>
-          <p:cNvPr id="7" name="Shape 5"/>
-          <p:cNvSpPr/>
-          <p:nvPr/>
-        </p:nvSpPr>
+      <p:pic>
+        <p:nvPicPr>
+          <p:cNvPr id="7" name="Image 0" descr="ppt\screens\account_map.png">    </p:cNvPr>
+          <p:cNvPicPr>
+            <a:picLocks noChangeAspect="1"/>
+          </p:cNvPicPr>
+          <p:nvPr/>
+        </p:nvPicPr>
+        <p:blipFill>
+          <a:blip r:embed="rId1"/>
+          <a:stretch>
+            <a:fillRect/>
+          </a:stretch>
+        </p:blipFill>
         <p:spPr>
           <a:xfrm>
             <a:off x="457200" y="1691640"/>
@@ -9807,137 +8951,33 @@
           <a:prstGeom prst="rect">
             <a:avLst/>
           </a:prstGeom>
-          <a:solidFill>
-            <a:srgbClr val="F5F7FA"/>
-          </a:solidFill>
-          <a:ln w="19050">
+        </p:spPr>
+      </p:pic>
+      <p:sp>
+        <p:nvSpPr>
+          <p:cNvPr id="8" name="Shape 5"/>
+          <p:cNvSpPr/>
+          <p:nvPr/>
+        </p:nvSpPr>
+        <p:spPr>
+          <a:xfrm>
+            <a:off x="457200" y="1691640"/>
+            <a:ext cx="6858000" cy="4480560"/>
+          </a:xfrm>
+          <a:prstGeom prst="rect">
+            <a:avLst/>
+          </a:prstGeom>
+          <a:ln w="12700">
             <a:solidFill>
               <a:srgbClr val="E1DFDD"/>
             </a:solidFill>
-            <a:prstDash val="dash"/>
+            <a:prstDash val="solid"/>
           </a:ln>
         </p:spPr>
       </p:sp>
       <p:sp>
         <p:nvSpPr>
-          <p:cNvPr id="8" name="Text 6"/>
-          <p:cNvSpPr/>
-          <p:nvPr/>
-        </p:nvSpPr>
-        <p:spPr>
-          <a:xfrm>
-            <a:off x="457200" y="3474720"/>
-            <a:ext cx="6858000" cy="457200"/>
-          </a:xfrm>
-          <a:prstGeom prst="rect">
-            <a:avLst/>
-          </a:prstGeom>
-          <a:noFill/>
-          <a:ln/>
-        </p:spPr>
-        <p:txBody>
-          <a:bodyPr wrap="square" rtlCol="0" anchor="ctr"/>
-          <a:lstStyle/>
-          <a:p>
-            <a:pPr algn="ctr" indent="0" marL="0">
-              <a:buNone/>
-            </a:pPr>
-            <a:r>
-              <a:rPr lang="en-US" sz="1600" b="1" dirty="0">
-                <a:solidFill>
-                  <a:srgbClr val="8A8886"/>
-                </a:solidFill>
-                <a:latin typeface="Segoe UI" pitchFamily="34" charset="0"/>
-                <a:ea typeface="Segoe UI" pitchFamily="34" charset="-122"/>
-                <a:cs typeface="Segoe UI" pitchFamily="34" charset="-120"/>
-              </a:rPr>
-              <a:t>📷  Screenshot</a:t>
-            </a:r>
-            <a:endParaRPr lang="en-US" sz="1600" dirty="0"/>
-          </a:p>
-        </p:txBody>
-      </p:sp>
-      <p:sp>
-        <p:nvSpPr>
-          <p:cNvPr id="9" name="Text 7"/>
-          <p:cNvSpPr/>
-          <p:nvPr/>
-        </p:nvSpPr>
-        <p:spPr>
-          <a:xfrm>
-            <a:off x="731520" y="3977640"/>
-            <a:ext cx="6309360" cy="457200"/>
-          </a:xfrm>
-          <a:prstGeom prst="rect">
-            <a:avLst/>
-          </a:prstGeom>
-          <a:noFill/>
-          <a:ln/>
-        </p:spPr>
-        <p:txBody>
-          <a:bodyPr wrap="square" rtlCol="0" anchor="ctr"/>
-          <a:lstStyle/>
-          <a:p>
-            <a:pPr algn="ctr" indent="0" marL="0">
-              <a:buNone/>
-            </a:pPr>
-            <a:r>
-              <a:rPr lang="en-US" sz="1100" dirty="0">
-                <a:solidFill>
-                  <a:srgbClr val="8A8886"/>
-                </a:solidFill>
-                <a:latin typeface="Segoe UI" pitchFamily="34" charset="0"/>
-                <a:ea typeface="Segoe UI" pitchFamily="34" charset="-122"/>
-                <a:cs typeface="Segoe UI" pitchFamily="34" charset="-120"/>
-              </a:rPr>
-              <a:t>Cedents &amp; Contacts → Account Map  (or the account form tab)</a:t>
-            </a:r>
-            <a:endParaRPr lang="en-US" sz="1100" dirty="0"/>
-          </a:p>
-        </p:txBody>
-      </p:sp>
-      <p:sp>
-        <p:nvSpPr>
-          <p:cNvPr id="10" name="Text 8"/>
-          <p:cNvSpPr/>
-          <p:nvPr/>
-        </p:nvSpPr>
-        <p:spPr>
-          <a:xfrm>
-            <a:off x="457200" y="5760720"/>
-            <a:ext cx="6858000" cy="320040"/>
-          </a:xfrm>
-          <a:prstGeom prst="rect">
-            <a:avLst/>
-          </a:prstGeom>
-          <a:noFill/>
-          <a:ln/>
-        </p:spPr>
-        <p:txBody>
-          <a:bodyPr wrap="square" rtlCol="0" anchor="ctr"/>
-          <a:lstStyle/>
-          <a:p>
-            <a:pPr algn="ctr" indent="0" marL="0">
-              <a:buNone/>
-            </a:pPr>
-            <a:r>
-              <a:rPr lang="en-US" sz="900" i="1" dirty="0">
-                <a:solidFill>
-                  <a:srgbClr val="8A8886"/>
-                </a:solidFill>
-                <a:latin typeface="Segoe UI" pitchFamily="34" charset="0"/>
-                <a:ea typeface="Segoe UI" pitchFamily="34" charset="-122"/>
-                <a:cs typeface="Segoe UI" pitchFamily="34" charset="-120"/>
-              </a:rPr>
-              <a:t>Paste the live screen capture here</a:t>
-            </a:r>
-            <a:endParaRPr lang="en-US" sz="900" dirty="0"/>
-          </a:p>
-        </p:txBody>
-      </p:sp>
-      <p:sp>
-        <p:nvSpPr>
-          <p:cNvPr id="11" name="Text 9"/>
+          <p:cNvPr id="9" name="Text 6"/>
           <p:cNvSpPr/>
           <p:nvPr/>
         </p:nvSpPr>
@@ -9976,7 +9016,7 @@
       </p:sp>
       <p:sp>
         <p:nvSpPr>
-          <p:cNvPr id="12" name="Shape 10"/>
+          <p:cNvPr id="10" name="Shape 7"/>
           <p:cNvSpPr/>
           <p:nvPr/>
         </p:nvSpPr>
@@ -9996,7 +9036,7 @@
       </p:sp>
       <p:sp>
         <p:nvSpPr>
-          <p:cNvPr id="13" name="Text 11"/>
+          <p:cNvPr id="11" name="Text 8"/>
           <p:cNvSpPr/>
           <p:nvPr/>
         </p:nvSpPr>
@@ -10035,7 +9075,7 @@
       </p:sp>
       <p:sp>
         <p:nvSpPr>
-          <p:cNvPr id="14" name="Text 12"/>
+          <p:cNvPr id="12" name="Text 9"/>
           <p:cNvSpPr/>
           <p:nvPr/>
         </p:nvSpPr>
@@ -10074,7 +9114,7 @@
       </p:sp>
       <p:sp>
         <p:nvSpPr>
-          <p:cNvPr id="15" name="Text 13"/>
+          <p:cNvPr id="13" name="Text 10"/>
           <p:cNvSpPr/>
           <p:nvPr/>
         </p:nvSpPr>
@@ -10313,12 +9353,20 @@
           </a:p>
         </p:txBody>
       </p:sp>
-      <p:sp>
-        <p:nvSpPr>
-          <p:cNvPr id="5" name="Shape 3"/>
-          <p:cNvSpPr/>
-          <p:nvPr/>
-        </p:nvSpPr>
+      <p:pic>
+        <p:nvPicPr>
+          <p:cNvPr id="5" name="Image 0" descr="ppt\screens\tpa_360.png">    </p:cNvPr>
+          <p:cNvPicPr>
+            <a:picLocks noChangeAspect="1"/>
+          </p:cNvPicPr>
+          <p:nvPr/>
+        </p:nvPicPr>
+        <p:blipFill>
+          <a:blip r:embed="rId1"/>
+          <a:stretch>
+            <a:fillRect/>
+          </a:stretch>
+        </p:blipFill>
         <p:spPr>
           <a:xfrm>
             <a:off x="457200" y="1691640"/>
@@ -10327,137 +9375,33 @@
           <a:prstGeom prst="rect">
             <a:avLst/>
           </a:prstGeom>
-          <a:solidFill>
-            <a:srgbClr val="F5F7FA"/>
-          </a:solidFill>
-          <a:ln w="19050">
+        </p:spPr>
+      </p:pic>
+      <p:sp>
+        <p:nvSpPr>
+          <p:cNvPr id="6" name="Shape 3"/>
+          <p:cNvSpPr/>
+          <p:nvPr/>
+        </p:nvSpPr>
+        <p:spPr>
+          <a:xfrm>
+            <a:off x="457200" y="1691640"/>
+            <a:ext cx="6858000" cy="4480560"/>
+          </a:xfrm>
+          <a:prstGeom prst="rect">
+            <a:avLst/>
+          </a:prstGeom>
+          <a:ln w="12700">
             <a:solidFill>
               <a:srgbClr val="E1DFDD"/>
             </a:solidFill>
-            <a:prstDash val="dash"/>
+            <a:prstDash val="solid"/>
           </a:ln>
         </p:spPr>
       </p:sp>
       <p:sp>
         <p:nvSpPr>
-          <p:cNvPr id="6" name="Text 4"/>
-          <p:cNvSpPr/>
-          <p:nvPr/>
-        </p:nvSpPr>
-        <p:spPr>
-          <a:xfrm>
-            <a:off x="457200" y="3474720"/>
-            <a:ext cx="6858000" cy="457200"/>
-          </a:xfrm>
-          <a:prstGeom prst="rect">
-            <a:avLst/>
-          </a:prstGeom>
-          <a:noFill/>
-          <a:ln/>
-        </p:spPr>
-        <p:txBody>
-          <a:bodyPr wrap="square" rtlCol="0" anchor="ctr"/>
-          <a:lstStyle/>
-          <a:p>
-            <a:pPr algn="ctr" indent="0" marL="0">
-              <a:buNone/>
-            </a:pPr>
-            <a:r>
-              <a:rPr lang="en-US" sz="1600" b="1" dirty="0">
-                <a:solidFill>
-                  <a:srgbClr val="8A8886"/>
-                </a:solidFill>
-                <a:latin typeface="Segoe UI" pitchFamily="34" charset="0"/>
-                <a:ea typeface="Segoe UI" pitchFamily="34" charset="-122"/>
-                <a:cs typeface="Segoe UI" pitchFamily="34" charset="-120"/>
-              </a:rPr>
-              <a:t>📷  Screenshot</a:t>
-            </a:r>
-            <a:endParaRPr lang="en-US" sz="1600" dirty="0"/>
-          </a:p>
-        </p:txBody>
-      </p:sp>
-      <p:sp>
-        <p:nvSpPr>
-          <p:cNvPr id="7" name="Text 5"/>
-          <p:cNvSpPr/>
-          <p:nvPr/>
-        </p:nvSpPr>
-        <p:spPr>
-          <a:xfrm>
-            <a:off x="731520" y="3977640"/>
-            <a:ext cx="6309360" cy="457200"/>
-          </a:xfrm>
-          <a:prstGeom prst="rect">
-            <a:avLst/>
-          </a:prstGeom>
-          <a:noFill/>
-          <a:ln/>
-        </p:spPr>
-        <p:txBody>
-          <a:bodyPr wrap="square" rtlCol="0" anchor="ctr"/>
-          <a:lstStyle/>
-          <a:p>
-            <a:pPr algn="ctr" indent="0" marL="0">
-              <a:buNone/>
-            </a:pPr>
-            <a:r>
-              <a:rPr lang="en-US" sz="1100" dirty="0">
-                <a:solidFill>
-                  <a:srgbClr val="8A8886"/>
-                </a:solidFill>
-                <a:latin typeface="Segoe UI" pitchFamily="34" charset="0"/>
-                <a:ea typeface="Segoe UI" pitchFamily="34" charset="-122"/>
-                <a:cs typeface="Segoe UI" pitchFamily="34" charset="-120"/>
-              </a:rPr>
-              <a:t>Partner Views → TPAs → Illumifin</a:t>
-            </a:r>
-            <a:endParaRPr lang="en-US" sz="1100" dirty="0"/>
-          </a:p>
-        </p:txBody>
-      </p:sp>
-      <p:sp>
-        <p:nvSpPr>
-          <p:cNvPr id="8" name="Text 6"/>
-          <p:cNvSpPr/>
-          <p:nvPr/>
-        </p:nvSpPr>
-        <p:spPr>
-          <a:xfrm>
-            <a:off x="457200" y="5760720"/>
-            <a:ext cx="6858000" cy="320040"/>
-          </a:xfrm>
-          <a:prstGeom prst="rect">
-            <a:avLst/>
-          </a:prstGeom>
-          <a:noFill/>
-          <a:ln/>
-        </p:spPr>
-        <p:txBody>
-          <a:bodyPr wrap="square" rtlCol="0" anchor="ctr"/>
-          <a:lstStyle/>
-          <a:p>
-            <a:pPr algn="ctr" indent="0" marL="0">
-              <a:buNone/>
-            </a:pPr>
-            <a:r>
-              <a:rPr lang="en-US" sz="900" i="1" dirty="0">
-                <a:solidFill>
-                  <a:srgbClr val="8A8886"/>
-                </a:solidFill>
-                <a:latin typeface="Segoe UI" pitchFamily="34" charset="0"/>
-                <a:ea typeface="Segoe UI" pitchFamily="34" charset="-122"/>
-                <a:cs typeface="Segoe UI" pitchFamily="34" charset="-120"/>
-              </a:rPr>
-              <a:t>Paste the live screen capture here</a:t>
-            </a:r>
-            <a:endParaRPr lang="en-US" sz="900" dirty="0"/>
-          </a:p>
-        </p:txBody>
-      </p:sp>
-      <p:sp>
-        <p:nvSpPr>
-          <p:cNvPr id="9" name="Text 7"/>
+          <p:cNvPr id="7" name="Text 4"/>
           <p:cNvSpPr/>
           <p:nvPr/>
         </p:nvSpPr>
@@ -10496,7 +9440,7 @@
       </p:sp>
       <p:sp>
         <p:nvSpPr>
-          <p:cNvPr id="10" name="Shape 8"/>
+          <p:cNvPr id="8" name="Shape 5"/>
           <p:cNvSpPr/>
           <p:nvPr/>
         </p:nvSpPr>
@@ -10516,7 +9460,7 @@
       </p:sp>
       <p:sp>
         <p:nvSpPr>
-          <p:cNvPr id="11" name="Text 9"/>
+          <p:cNvPr id="9" name="Text 6"/>
           <p:cNvSpPr/>
           <p:nvPr/>
         </p:nvSpPr>
@@ -10555,7 +9499,7 @@
       </p:sp>
       <p:sp>
         <p:nvSpPr>
-          <p:cNvPr id="12" name="Text 10"/>
+          <p:cNvPr id="10" name="Text 7"/>
           <p:cNvSpPr/>
           <p:nvPr/>
         </p:nvSpPr>
@@ -10594,7 +9538,7 @@
       </p:sp>
       <p:sp>
         <p:nvSpPr>
-          <p:cNvPr id="13" name="Text 11"/>
+          <p:cNvPr id="11" name="Text 8"/>
           <p:cNvSpPr/>
           <p:nvPr/>
         </p:nvSpPr>
@@ -10894,12 +9838,20 @@
           </a:p>
         </p:txBody>
       </p:sp>
-      <p:sp>
-        <p:nvSpPr>
-          <p:cNvPr id="7" name="Shape 5"/>
-          <p:cNvSpPr/>
-          <p:nvPr/>
-        </p:nvSpPr>
+      <p:pic>
+        <p:nvPicPr>
+          <p:cNvPr id="7" name="Image 0" descr="ppt\screens\treaties.png">    </p:cNvPr>
+          <p:cNvPicPr>
+            <a:picLocks noChangeAspect="1"/>
+          </p:cNvPicPr>
+          <p:nvPr/>
+        </p:nvPicPr>
+        <p:blipFill>
+          <a:blip r:embed="rId1"/>
+          <a:stretch>
+            <a:fillRect/>
+          </a:stretch>
+        </p:blipFill>
         <p:spPr>
           <a:xfrm>
             <a:off x="457200" y="1691640"/>
@@ -10908,137 +9860,33 @@
           <a:prstGeom prst="rect">
             <a:avLst/>
           </a:prstGeom>
-          <a:solidFill>
-            <a:srgbClr val="F5F7FA"/>
-          </a:solidFill>
-          <a:ln w="19050">
+        </p:spPr>
+      </p:pic>
+      <p:sp>
+        <p:nvSpPr>
+          <p:cNvPr id="8" name="Shape 5"/>
+          <p:cNvSpPr/>
+          <p:nvPr/>
+        </p:nvSpPr>
+        <p:spPr>
+          <a:xfrm>
+            <a:off x="457200" y="1691640"/>
+            <a:ext cx="6858000" cy="4480560"/>
+          </a:xfrm>
+          <a:prstGeom prst="rect">
+            <a:avLst/>
+          </a:prstGeom>
+          <a:ln w="12700">
             <a:solidFill>
               <a:srgbClr val="E1DFDD"/>
             </a:solidFill>
-            <a:prstDash val="dash"/>
+            <a:prstDash val="solid"/>
           </a:ln>
         </p:spPr>
       </p:sp>
       <p:sp>
         <p:nvSpPr>
-          <p:cNvPr id="8" name="Text 6"/>
-          <p:cNvSpPr/>
-          <p:nvPr/>
-        </p:nvSpPr>
-        <p:spPr>
-          <a:xfrm>
-            <a:off x="457200" y="3474720"/>
-            <a:ext cx="6858000" cy="457200"/>
-          </a:xfrm>
-          <a:prstGeom prst="rect">
-            <a:avLst/>
-          </a:prstGeom>
-          <a:noFill/>
-          <a:ln/>
-        </p:spPr>
-        <p:txBody>
-          <a:bodyPr wrap="square" rtlCol="0" anchor="ctr"/>
-          <a:lstStyle/>
-          <a:p>
-            <a:pPr algn="ctr" indent="0" marL="0">
-              <a:buNone/>
-            </a:pPr>
-            <a:r>
-              <a:rPr lang="en-US" sz="1600" b="1" dirty="0">
-                <a:solidFill>
-                  <a:srgbClr val="8A8886"/>
-                </a:solidFill>
-                <a:latin typeface="Segoe UI" pitchFamily="34" charset="0"/>
-                <a:ea typeface="Segoe UI" pitchFamily="34" charset="-122"/>
-                <a:cs typeface="Segoe UI" pitchFamily="34" charset="-120"/>
-              </a:rPr>
-              <a:t>📷  Screenshot</a:t>
-            </a:r>
-            <a:endParaRPr lang="en-US" sz="1600" dirty="0"/>
-          </a:p>
-        </p:txBody>
-      </p:sp>
-      <p:sp>
-        <p:nvSpPr>
-          <p:cNvPr id="9" name="Text 7"/>
-          <p:cNvSpPr/>
-          <p:nvPr/>
-        </p:nvSpPr>
-        <p:spPr>
-          <a:xfrm>
-            <a:off x="731520" y="3977640"/>
-            <a:ext cx="6309360" cy="457200"/>
-          </a:xfrm>
-          <a:prstGeom prst="rect">
-            <a:avLst/>
-          </a:prstGeom>
-          <a:noFill/>
-          <a:ln/>
-        </p:spPr>
-        <p:txBody>
-          <a:bodyPr wrap="square" rtlCol="0" anchor="ctr"/>
-          <a:lstStyle/>
-          <a:p>
-            <a:pPr algn="ctr" indent="0" marL="0">
-              <a:buNone/>
-            </a:pPr>
-            <a:r>
-              <a:rPr lang="en-US" sz="1100" dirty="0">
-                <a:solidFill>
-                  <a:srgbClr val="8A8886"/>
-                </a:solidFill>
-                <a:latin typeface="Segoe UI" pitchFamily="34" charset="0"/>
-                <a:ea typeface="Segoe UI" pitchFamily="34" charset="-122"/>
-                <a:cs typeface="Segoe UI" pitchFamily="34" charset="-120"/>
-              </a:rPr>
-              <a:t>Treaties  →  Reserve Adequacy  →  Partnership Ratings</a:t>
-            </a:r>
-            <a:endParaRPr lang="en-US" sz="1100" dirty="0"/>
-          </a:p>
-        </p:txBody>
-      </p:sp>
-      <p:sp>
-        <p:nvSpPr>
-          <p:cNvPr id="10" name="Text 8"/>
-          <p:cNvSpPr/>
-          <p:nvPr/>
-        </p:nvSpPr>
-        <p:spPr>
-          <a:xfrm>
-            <a:off x="457200" y="5760720"/>
-            <a:ext cx="6858000" cy="320040"/>
-          </a:xfrm>
-          <a:prstGeom prst="rect">
-            <a:avLst/>
-          </a:prstGeom>
-          <a:noFill/>
-          <a:ln/>
-        </p:spPr>
-        <p:txBody>
-          <a:bodyPr wrap="square" rtlCol="0" anchor="ctr"/>
-          <a:lstStyle/>
-          <a:p>
-            <a:pPr algn="ctr" indent="0" marL="0">
-              <a:buNone/>
-            </a:pPr>
-            <a:r>
-              <a:rPr lang="en-US" sz="900" i="1" dirty="0">
-                <a:solidFill>
-                  <a:srgbClr val="8A8886"/>
-                </a:solidFill>
-                <a:latin typeface="Segoe UI" pitchFamily="34" charset="0"/>
-                <a:ea typeface="Segoe UI" pitchFamily="34" charset="-122"/>
-                <a:cs typeface="Segoe UI" pitchFamily="34" charset="-120"/>
-              </a:rPr>
-              <a:t>Paste the live screen capture here</a:t>
-            </a:r>
-            <a:endParaRPr lang="en-US" sz="900" dirty="0"/>
-          </a:p>
-        </p:txBody>
-      </p:sp>
-      <p:sp>
-        <p:nvSpPr>
-          <p:cNvPr id="11" name="Text 9"/>
+          <p:cNvPr id="9" name="Text 6"/>
           <p:cNvSpPr/>
           <p:nvPr/>
         </p:nvSpPr>
@@ -11077,7 +9925,7 @@
       </p:sp>
       <p:sp>
         <p:nvSpPr>
-          <p:cNvPr id="12" name="Shape 10"/>
+          <p:cNvPr id="10" name="Shape 7"/>
           <p:cNvSpPr/>
           <p:nvPr/>
         </p:nvSpPr>
@@ -11097,7 +9945,7 @@
       </p:sp>
       <p:sp>
         <p:nvSpPr>
-          <p:cNvPr id="13" name="Text 11"/>
+          <p:cNvPr id="11" name="Text 8"/>
           <p:cNvSpPr/>
           <p:nvPr/>
         </p:nvSpPr>
@@ -11136,7 +9984,7 @@
       </p:sp>
       <p:sp>
         <p:nvSpPr>
-          <p:cNvPr id="14" name="Text 12"/>
+          <p:cNvPr id="12" name="Text 9"/>
           <p:cNvSpPr/>
           <p:nvPr/>
         </p:nvSpPr>
@@ -11175,7 +10023,7 @@
       </p:sp>
       <p:sp>
         <p:nvSpPr>
-          <p:cNvPr id="15" name="Text 13"/>
+          <p:cNvPr id="13" name="Text 10"/>
           <p:cNvSpPr/>
           <p:nvPr/>
         </p:nvSpPr>
@@ -11475,12 +10323,20 @@
           </a:p>
         </p:txBody>
       </p:sp>
-      <p:sp>
-        <p:nvSpPr>
-          <p:cNvPr id="7" name="Shape 5"/>
-          <p:cNvSpPr/>
-          <p:nvPr/>
-        </p:nvSpPr>
+      <p:pic>
+        <p:nvPicPr>
+          <p:cNvPr id="7" name="Image 0" descr="ppt\screens\risk_disputes.png">    </p:cNvPr>
+          <p:cNvPicPr>
+            <a:picLocks noChangeAspect="1"/>
+          </p:cNvPicPr>
+          <p:nvPr/>
+        </p:nvPicPr>
+        <p:blipFill>
+          <a:blip r:embed="rId1"/>
+          <a:stretch>
+            <a:fillRect/>
+          </a:stretch>
+        </p:blipFill>
         <p:spPr>
           <a:xfrm>
             <a:off x="457200" y="1691640"/>
@@ -11489,137 +10345,33 @@
           <a:prstGeom prst="rect">
             <a:avLst/>
           </a:prstGeom>
-          <a:solidFill>
-            <a:srgbClr val="F5F7FA"/>
-          </a:solidFill>
-          <a:ln w="19050">
+        </p:spPr>
+      </p:pic>
+      <p:sp>
+        <p:nvSpPr>
+          <p:cNvPr id="8" name="Shape 5"/>
+          <p:cNvSpPr/>
+          <p:nvPr/>
+        </p:nvSpPr>
+        <p:spPr>
+          <a:xfrm>
+            <a:off x="457200" y="1691640"/>
+            <a:ext cx="6858000" cy="4480560"/>
+          </a:xfrm>
+          <a:prstGeom prst="rect">
+            <a:avLst/>
+          </a:prstGeom>
+          <a:ln w="12700">
             <a:solidFill>
               <a:srgbClr val="E1DFDD"/>
             </a:solidFill>
-            <a:prstDash val="dash"/>
+            <a:prstDash val="solid"/>
           </a:ln>
         </p:spPr>
       </p:sp>
       <p:sp>
         <p:nvSpPr>
-          <p:cNvPr id="8" name="Text 6"/>
-          <p:cNvSpPr/>
-          <p:nvPr/>
-        </p:nvSpPr>
-        <p:spPr>
-          <a:xfrm>
-            <a:off x="457200" y="3474720"/>
-            <a:ext cx="6858000" cy="457200"/>
-          </a:xfrm>
-          <a:prstGeom prst="rect">
-            <a:avLst/>
-          </a:prstGeom>
-          <a:noFill/>
-          <a:ln/>
-        </p:spPr>
-        <p:txBody>
-          <a:bodyPr wrap="square" rtlCol="0" anchor="ctr"/>
-          <a:lstStyle/>
-          <a:p>
-            <a:pPr algn="ctr" indent="0" marL="0">
-              <a:buNone/>
-            </a:pPr>
-            <a:r>
-              <a:rPr lang="en-US" sz="1600" b="1" dirty="0">
-                <a:solidFill>
-                  <a:srgbClr val="8A8886"/>
-                </a:solidFill>
-                <a:latin typeface="Segoe UI" pitchFamily="34" charset="0"/>
-                <a:ea typeface="Segoe UI" pitchFamily="34" charset="-122"/>
-                <a:cs typeface="Segoe UI" pitchFamily="34" charset="-120"/>
-              </a:rPr>
-              <a:t>📷  Screenshot</a:t>
-            </a:r>
-            <a:endParaRPr lang="en-US" sz="1600" dirty="0"/>
-          </a:p>
-        </p:txBody>
-      </p:sp>
-      <p:sp>
-        <p:nvSpPr>
-          <p:cNvPr id="9" name="Text 7"/>
-          <p:cNvSpPr/>
-          <p:nvPr/>
-        </p:nvSpPr>
-        <p:spPr>
-          <a:xfrm>
-            <a:off x="731520" y="3977640"/>
-            <a:ext cx="6309360" cy="457200"/>
-          </a:xfrm>
-          <a:prstGeom prst="rect">
-            <a:avLst/>
-          </a:prstGeom>
-          <a:noFill/>
-          <a:ln/>
-        </p:spPr>
-        <p:txBody>
-          <a:bodyPr wrap="square" rtlCol="0" anchor="ctr"/>
-          <a:lstStyle/>
-          <a:p>
-            <a:pPr algn="ctr" indent="0" marL="0">
-              <a:buNone/>
-            </a:pPr>
-            <a:r>
-              <a:rPr lang="en-US" sz="1100" dirty="0">
-                <a:solidFill>
-                  <a:srgbClr val="8A8886"/>
-                </a:solidFill>
-                <a:latin typeface="Segoe UI" pitchFamily="34" charset="0"/>
-                <a:ea typeface="Segoe UI" pitchFamily="34" charset="-122"/>
-                <a:cs typeface="Segoe UI" pitchFamily="34" charset="-120"/>
-              </a:rPr>
-              <a:t>Risk Assessments  →  Disputes</a:t>
-            </a:r>
-            <a:endParaRPr lang="en-US" sz="1100" dirty="0"/>
-          </a:p>
-        </p:txBody>
-      </p:sp>
-      <p:sp>
-        <p:nvSpPr>
-          <p:cNvPr id="10" name="Text 8"/>
-          <p:cNvSpPr/>
-          <p:nvPr/>
-        </p:nvSpPr>
-        <p:spPr>
-          <a:xfrm>
-            <a:off x="457200" y="5760720"/>
-            <a:ext cx="6858000" cy="320040"/>
-          </a:xfrm>
-          <a:prstGeom prst="rect">
-            <a:avLst/>
-          </a:prstGeom>
-          <a:noFill/>
-          <a:ln/>
-        </p:spPr>
-        <p:txBody>
-          <a:bodyPr wrap="square" rtlCol="0" anchor="ctr"/>
-          <a:lstStyle/>
-          <a:p>
-            <a:pPr algn="ctr" indent="0" marL="0">
-              <a:buNone/>
-            </a:pPr>
-            <a:r>
-              <a:rPr lang="en-US" sz="900" i="1" dirty="0">
-                <a:solidFill>
-                  <a:srgbClr val="8A8886"/>
-                </a:solidFill>
-                <a:latin typeface="Segoe UI" pitchFamily="34" charset="0"/>
-                <a:ea typeface="Segoe UI" pitchFamily="34" charset="-122"/>
-                <a:cs typeface="Segoe UI" pitchFamily="34" charset="-120"/>
-              </a:rPr>
-              <a:t>Paste the live screen capture here</a:t>
-            </a:r>
-            <a:endParaRPr lang="en-US" sz="900" dirty="0"/>
-          </a:p>
-        </p:txBody>
-      </p:sp>
-      <p:sp>
-        <p:nvSpPr>
-          <p:cNvPr id="11" name="Text 9"/>
+          <p:cNvPr id="9" name="Text 6"/>
           <p:cNvSpPr/>
           <p:nvPr/>
         </p:nvSpPr>
@@ -11658,7 +10410,7 @@
       </p:sp>
       <p:sp>
         <p:nvSpPr>
-          <p:cNvPr id="12" name="Shape 10"/>
+          <p:cNvPr id="10" name="Shape 7"/>
           <p:cNvSpPr/>
           <p:nvPr/>
         </p:nvSpPr>
@@ -11678,7 +10430,7 @@
       </p:sp>
       <p:sp>
         <p:nvSpPr>
-          <p:cNvPr id="13" name="Text 11"/>
+          <p:cNvPr id="11" name="Text 8"/>
           <p:cNvSpPr/>
           <p:nvPr/>
         </p:nvSpPr>
@@ -11717,7 +10469,7 @@
       </p:sp>
       <p:sp>
         <p:nvSpPr>
-          <p:cNvPr id="14" name="Text 12"/>
+          <p:cNvPr id="12" name="Text 9"/>
           <p:cNvSpPr/>
           <p:nvPr/>
         </p:nvSpPr>
@@ -11756,7 +10508,7 @@
       </p:sp>
       <p:sp>
         <p:nvSpPr>
-          <p:cNvPr id="15" name="Text 13"/>
+          <p:cNvPr id="13" name="Text 10"/>
           <p:cNvSpPr/>
           <p:nvPr/>
         </p:nvSpPr>

</xml_diff>